<commit_message>
Präsentation umgebaut: Vergleich nach vorn, Schlussfolie ans Ende
Der Vergleich „eine Zeile gegen jede Position" stand bisher auf einer
eigenen Folie hinter dem Prüfen-Screen, der dasselbe schon zeigte. Er
sitzt jetzt auf der Problemfolie, wo er die Wendung ist. Der frei
gewordene Platz trägt den Schluss: was die App ist, was sie nicht
speichert und für wen sie gebaut wurde.

Zusätzlich liegt die Präsentation als PDF bei.

Co-Authored-By: Claude Opus 5 <noreply@anthropic.com>
Claude-Session: https://claude.ai/code/session_01Wqjsmvv2jzDeymmgEG8Bji
</commit_message>
<xml_diff>
--- a/praesentation/Receipt-AI.pptx
+++ b/praesentation/Receipt-AI.pptx
@@ -597,7 +597,7 @@
           <a:p>
             <a:r>
               <a:rPr lang="en-US" dirty="0"/>
-              <a:t>Das Problem ist nicht die Summe – die kennt jeder. Das Problem ist, dass die Summe nichts erklärt.</a:t>
+              <a:t>Derselbe Bon, zwei Datenbestände. Erst durch die untere Fassung wird beantwortbar, wie viel im Jahr für Käse draufgeht oder ob die Butter teurer geworden ist.</a:t>
             </a:r>
             <a:endParaRPr lang="en-US" dirty="0"/>
           </a:p>
@@ -773,7 +773,7 @@
           <a:p>
             <a:r>
               <a:rPr lang="en-US" dirty="0"/>
-              <a:t>Derselbe Bon, zwei Datenbestände. Rechts steht die Grundlage für alles Weitere: Preisverlauf, Kategorien, Gesundheit, Einkaufszettel.</a:t>
+              <a:t>Die Kategorien vergibt die KI beim Erkennen. Wer eine Kategorie ändert, ändert sie rückwirkend für alle Einkäufe.</a:t>
             </a:r>
             <a:endParaRPr lang="en-US" dirty="0"/>
           </a:p>
@@ -861,7 +861,7 @@
           <a:p>
             <a:r>
               <a:rPr lang="en-US" dirty="0"/>
-              <a:t>Die Kategorien vergibt die KI beim Erkennen. Wer eine Kategorie ändert, ändert sie rückwirkend für alle Einkäufe.</a:t>
+              <a:t>Der Preisverlauf entsteht ganz von selbst, ohne dass jemand Preise pflegt. Er zeigt auch, wenn ein Produkt überall teurer wird.</a:t>
             </a:r>
             <a:endParaRPr lang="en-US" dirty="0"/>
           </a:p>
@@ -949,7 +949,7 @@
           <a:p>
             <a:r>
               <a:rPr lang="en-US" dirty="0"/>
-              <a:t>Der Preisverlauf entsteht ganz von selbst, ohne dass jemand Preise pflegt. Er zeigt auch, wenn ein Produkt überall teurer wird.</a:t>
+              <a:t>Wichtig: Die App bewertet niemanden. Sie rechnet aus, was du selbst als gut oder ungünstig eingestellt hast – und zeigt es in Euro, nicht in Kalorien.</a:t>
             </a:r>
             <a:endParaRPr lang="en-US" dirty="0"/>
           </a:p>
@@ -1037,7 +1037,7 @@
           <a:p>
             <a:r>
               <a:rPr lang="en-US" dirty="0"/>
-              <a:t>Wichtig: Die App bewertet niemanden. Sie rechnet aus, was du selbst als gut oder ungünstig eingestellt hast – und zeigt es in Euro, nicht in Kalorien.</a:t>
+              <a:t>Vorgeschlagen wird nur, was mindestens dreimal in gleichmäßigem Abstand gekauft wurde. Alles andere bleibt draußen, damit der Zettel nicht zumüllt.</a:t>
             </a:r>
             <a:endParaRPr lang="en-US" dirty="0"/>
           </a:p>
@@ -1125,7 +1125,7 @@
           <a:p>
             <a:r>
               <a:rPr lang="en-US" dirty="0"/>
-              <a:t>Vorgeschlagen wird nur, was mindestens dreimal in gleichmäßigem Abstand gekauft wurde. Alles andere bleibt draußen, damit der Zettel nicht zumüllt.</a:t>
+              <a:t>Ehrlich zum Schluss: keine Nutzerzahlen, keine gemessene Ersparnis. Die App ist für einen Haushalt gebaut und tut genau das, was auf den Folien zu sehen war.</a:t>
             </a:r>
             <a:endParaRPr lang="en-US" dirty="0"/>
           </a:p>
@@ -1643,8 +1643,8 @@
         </p:nvSpPr>
         <p:spPr>
           <a:xfrm>
-            <a:off x="594360" y="960120"/>
-            <a:ext cx="4480560" cy="1005840"/>
+            <a:off x="594360" y="1188720"/>
+            <a:ext cx="3977640" cy="1005840"/>
           </a:xfrm>
           <a:prstGeom prst="rect">
             <a:avLst/>
@@ -1691,7 +1691,7 @@
                 <a:ea typeface="Arial" pitchFamily="34" charset="-122"/>
                 <a:cs typeface="Arial" pitchFamily="34" charset="-120"/>
               </a:rPr>
-              <a:t>Du weißt nicht, wofür.</a:t>
+              <a:t>Nicht, wofür.</a:t>
             </a:r>
             <a:endParaRPr lang="en-US" sz="3200" dirty="0"/>
           </a:p>
@@ -1705,8 +1705,8 @@
         </p:nvSpPr>
         <p:spPr>
           <a:xfrm>
-            <a:off x="594360" y="2514600"/>
-            <a:ext cx="4206240" cy="1463040"/>
+            <a:off x="594360" y="2377440"/>
+            <a:ext cx="3886200" cy="1371600"/>
           </a:xfrm>
           <a:prstGeom prst="rect">
             <a:avLst/>
@@ -1733,7 +1733,7 @@
                 <a:ea typeface="Arial" pitchFamily="34" charset="-122"/>
                 <a:cs typeface="Arial" pitchFamily="34" charset="-120"/>
               </a:rPr>
-              <a:t>Am Monatsende steht eine Zahl. Ein klassisches Haushaltsbuch erfasst pro Einkauf genau eine Summe – und damit ist der Einkauf für immer eine Zeile. Was drin war, weiß danach niemand mehr.</a:t>
+              <a:t>Ein klassisches Haushaltsbuch erfasst pro Einkauf genau eine Summe. Damit ist der Einkauf für immer eine Zeile – was drin war, weiß danach niemand mehr.</a:t>
             </a:r>
             <a:endParaRPr lang="en-US" sz="1400" dirty="0"/>
           </a:p>
@@ -1747,12 +1747,202 @@
         </p:nvSpPr>
         <p:spPr>
           <a:xfrm>
-            <a:off x="5257800" y="960120"/>
-            <a:ext cx="3291840" cy="3200400"/>
+            <a:off x="4846320" y="548640"/>
+            <a:ext cx="3703320" cy="1188720"/>
           </a:xfrm>
           <a:prstGeom prst="roundRect">
             <a:avLst>
-              <a:gd name="adj" fmla="val 4571"/>
+              <a:gd name="adj" fmla="val 12308"/>
+            </a:avLst>
+          </a:prstGeom>
+          <a:solidFill>
+            <a:srgbClr val="FAFAF8"/>
+          </a:solidFill>
+          <a:ln w="9525">
+            <a:solidFill>
+              <a:srgbClr val="E7E9E4"/>
+            </a:solidFill>
+            <a:prstDash val="solid"/>
+          </a:ln>
+          <a:effectLst>
+            <a:outerShdw sx="100000" sy="100000" kx="0" ky="0" algn="bl" rotWithShape="0" blurRad="177800" dist="38100" dir="5400000">
+              <a:srgbClr val="000000">
+                <a:alpha val="10000"/>
+              </a:srgbClr>
+            </a:outerShdw>
+          </a:effectLst>
+        </p:spPr>
+      </p:sp>
+      <p:sp>
+        <p:nvSpPr>
+          <p:cNvPr id="5" name="Text 3"/>
+          <p:cNvSpPr/>
+          <p:nvPr/>
+        </p:nvSpPr>
+        <p:spPr>
+          <a:xfrm>
+            <a:off x="5120640" y="731520"/>
+            <a:ext cx="3154680" cy="274320"/>
+          </a:xfrm>
+          <a:prstGeom prst="rect">
+            <a:avLst/>
+          </a:prstGeom>
+          <a:noFill/>
+          <a:ln/>
+        </p:spPr>
+        <p:txBody>
+          <a:bodyPr wrap="square" lIns="0" tIns="0" rIns="0" bIns="0" rtlCol="0" anchor="ctr"/>
+          <a:lstStyle/>
+          <a:p>
+            <a:pPr indent="0" marL="0">
+              <a:buNone/>
+            </a:pPr>
+            <a:r>
+              <a:rPr lang="en-US" sz="1100" b="1" dirty="0">
+                <a:solidFill>
+                  <a:srgbClr val="77807A"/>
+                </a:solidFill>
+                <a:latin typeface="Arial" pitchFamily="34" charset="0"/>
+                <a:ea typeface="Arial" pitchFamily="34" charset="-122"/>
+                <a:cs typeface="Arial" pitchFamily="34" charset="-120"/>
+              </a:rPr>
+              <a:t>Klassisches Haushaltsbuch</a:t>
+            </a:r>
+            <a:endParaRPr lang="en-US" sz="1100" dirty="0"/>
+          </a:p>
+        </p:txBody>
+      </p:sp>
+      <p:sp>
+        <p:nvSpPr>
+          <p:cNvPr id="6" name="Text 4"/>
+          <p:cNvSpPr/>
+          <p:nvPr/>
+        </p:nvSpPr>
+        <p:spPr>
+          <a:xfrm>
+            <a:off x="5120640" y="1152144"/>
+            <a:ext cx="1371600" cy="310896"/>
+          </a:xfrm>
+          <a:prstGeom prst="rect">
+            <a:avLst/>
+          </a:prstGeom>
+          <a:noFill/>
+          <a:ln/>
+        </p:spPr>
+        <p:txBody>
+          <a:bodyPr wrap="square" lIns="0" tIns="0" rIns="0" bIns="0" rtlCol="0" anchor="ctr"/>
+          <a:lstStyle/>
+          <a:p>
+            <a:pPr indent="0" marL="0">
+              <a:buNone/>
+            </a:pPr>
+            <a:r>
+              <a:rPr lang="en-US" sz="1400" b="1" dirty="0">
+                <a:solidFill>
+                  <a:srgbClr val="12150F"/>
+                </a:solidFill>
+                <a:latin typeface="Arial" pitchFamily="34" charset="0"/>
+                <a:ea typeface="Arial" pitchFamily="34" charset="-122"/>
+                <a:cs typeface="Arial" pitchFamily="34" charset="-120"/>
+              </a:rPr>
+              <a:t>REWE</a:t>
+            </a:r>
+            <a:endParaRPr lang="en-US" sz="1400" dirty="0"/>
+          </a:p>
+        </p:txBody>
+      </p:sp>
+      <p:sp>
+        <p:nvSpPr>
+          <p:cNvPr id="7" name="Text 5"/>
+          <p:cNvSpPr/>
+          <p:nvPr/>
+        </p:nvSpPr>
+        <p:spPr>
+          <a:xfrm>
+            <a:off x="6492240" y="1152144"/>
+            <a:ext cx="1005840" cy="310896"/>
+          </a:xfrm>
+          <a:prstGeom prst="rect">
+            <a:avLst/>
+          </a:prstGeom>
+          <a:noFill/>
+          <a:ln/>
+        </p:spPr>
+        <p:txBody>
+          <a:bodyPr wrap="square" lIns="0" tIns="0" rIns="0" bIns="0" rtlCol="0" anchor="ctr"/>
+          <a:lstStyle/>
+          <a:p>
+            <a:pPr indent="0" marL="0">
+              <a:buNone/>
+            </a:pPr>
+            <a:r>
+              <a:rPr lang="en-US" sz="1050" dirty="0">
+                <a:solidFill>
+                  <a:srgbClr val="77807A"/>
+                </a:solidFill>
+                <a:latin typeface="Arial" pitchFamily="34" charset="0"/>
+                <a:ea typeface="Arial" pitchFamily="34" charset="-122"/>
+                <a:cs typeface="Arial" pitchFamily="34" charset="-120"/>
+              </a:rPr>
+              <a:t>02.08.2026</a:t>
+            </a:r>
+            <a:endParaRPr lang="en-US" sz="1050" dirty="0"/>
+          </a:p>
+        </p:txBody>
+      </p:sp>
+      <p:sp>
+        <p:nvSpPr>
+          <p:cNvPr id="8" name="Text 6"/>
+          <p:cNvSpPr/>
+          <p:nvPr/>
+        </p:nvSpPr>
+        <p:spPr>
+          <a:xfrm>
+            <a:off x="7223760" y="1133856"/>
+            <a:ext cx="1051560" cy="347472"/>
+          </a:xfrm>
+          <a:prstGeom prst="rect">
+            <a:avLst/>
+          </a:prstGeom>
+          <a:noFill/>
+          <a:ln/>
+        </p:spPr>
+        <p:txBody>
+          <a:bodyPr wrap="square" lIns="0" tIns="0" rIns="0" bIns="0" rtlCol="0" anchor="ctr"/>
+          <a:lstStyle/>
+          <a:p>
+            <a:pPr algn="r" indent="0" marL="0">
+              <a:buNone/>
+            </a:pPr>
+            <a:r>
+              <a:rPr lang="en-US" sz="1500" b="1" dirty="0">
+                <a:solidFill>
+                  <a:srgbClr val="12150F"/>
+                </a:solidFill>
+                <a:latin typeface="Arial" pitchFamily="34" charset="0"/>
+                <a:ea typeface="Arial" pitchFamily="34" charset="-122"/>
+                <a:cs typeface="Arial" pitchFamily="34" charset="-120"/>
+              </a:rPr>
+              <a:t>27,31 €</a:t>
+            </a:r>
+            <a:endParaRPr lang="en-US" sz="1500" dirty="0"/>
+          </a:p>
+        </p:txBody>
+      </p:sp>
+      <p:sp>
+        <p:nvSpPr>
+          <p:cNvPr id="9" name="Shape 7"/>
+          <p:cNvSpPr/>
+          <p:nvPr/>
+        </p:nvSpPr>
+        <p:spPr>
+          <a:xfrm>
+            <a:off x="4846320" y="1965960"/>
+            <a:ext cx="3703320" cy="2697480"/>
+          </a:xfrm>
+          <a:prstGeom prst="roundRect">
+            <a:avLst>
+              <a:gd name="adj" fmla="val 5424"/>
             </a:avLst>
           </a:prstGeom>
           <a:solidFill>
@@ -1775,14 +1965,14 @@
       </p:sp>
       <p:sp>
         <p:nvSpPr>
-          <p:cNvPr id="5" name="Text 3"/>
-          <p:cNvSpPr/>
-          <p:nvPr/>
-        </p:nvSpPr>
-        <p:spPr>
-          <a:xfrm>
-            <a:off x="5532120" y="1197864"/>
-            <a:ext cx="2743200" cy="274320"/>
+          <p:cNvPr id="10" name="Text 8"/>
+          <p:cNvSpPr/>
+          <p:nvPr/>
+        </p:nvSpPr>
+        <p:spPr>
+          <a:xfrm>
+            <a:off x="5120640" y="2167128"/>
+            <a:ext cx="3154680" cy="274320"/>
           </a:xfrm>
           <a:prstGeom prst="rect">
             <a:avLst/>
@@ -1800,51 +1990,106 @@
             <a:r>
               <a:rPr lang="en-US" sz="1100" b="1" dirty="0">
                 <a:solidFill>
+                  <a:srgbClr val="16915C"/>
+                </a:solidFill>
+                <a:latin typeface="Arial" pitchFamily="34" charset="0"/>
+                <a:ea typeface="Arial" pitchFamily="34" charset="-122"/>
+                <a:cs typeface="Arial" pitchFamily="34" charset="-120"/>
+              </a:rPr>
+              <a:t>Receipt AI</a:t>
+            </a:r>
+            <a:endParaRPr lang="en-US" sz="1100" dirty="0"/>
+          </a:p>
+        </p:txBody>
+      </p:sp>
+      <p:sp>
+        <p:nvSpPr>
+          <p:cNvPr id="11" name="Text 9"/>
+          <p:cNvSpPr/>
+          <p:nvPr/>
+        </p:nvSpPr>
+        <p:spPr>
+          <a:xfrm>
+            <a:off x="5120640" y="2560320"/>
+            <a:ext cx="2194560" cy="201168"/>
+          </a:xfrm>
+          <a:prstGeom prst="rect">
+            <a:avLst/>
+          </a:prstGeom>
+          <a:noFill/>
+          <a:ln/>
+        </p:spPr>
+        <p:txBody>
+          <a:bodyPr wrap="square" lIns="0" tIns="0" rIns="0" bIns="0" rtlCol="0" anchor="ctr"/>
+          <a:lstStyle/>
+          <a:p>
+            <a:pPr indent="0" marL="0">
+              <a:buNone/>
+            </a:pPr>
+            <a:r>
+              <a:rPr lang="en-US" sz="1150" b="1" dirty="0">
+                <a:solidFill>
+                  <a:srgbClr val="12150F"/>
+                </a:solidFill>
+                <a:latin typeface="Arial" pitchFamily="34" charset="0"/>
+                <a:ea typeface="Arial" pitchFamily="34" charset="-122"/>
+                <a:cs typeface="Arial" pitchFamily="34" charset="-120"/>
+              </a:rPr>
+              <a:t>H-Milch 1,5 %</a:t>
+            </a:r>
+            <a:endParaRPr lang="en-US" sz="1150" dirty="0"/>
+          </a:p>
+        </p:txBody>
+      </p:sp>
+      <p:sp>
+        <p:nvSpPr>
+          <p:cNvPr id="12" name="Text 10"/>
+          <p:cNvSpPr/>
+          <p:nvPr/>
+        </p:nvSpPr>
+        <p:spPr>
+          <a:xfrm>
+            <a:off x="5120640" y="2734056"/>
+            <a:ext cx="2194560" cy="182880"/>
+          </a:xfrm>
+          <a:prstGeom prst="rect">
+            <a:avLst/>
+          </a:prstGeom>
+          <a:noFill/>
+          <a:ln/>
+        </p:spPr>
+        <p:txBody>
+          <a:bodyPr wrap="square" lIns="0" tIns="0" rIns="0" bIns="0" rtlCol="0" anchor="ctr"/>
+          <a:lstStyle/>
+          <a:p>
+            <a:pPr indent="0" marL="0">
+              <a:buNone/>
+            </a:pPr>
+            <a:r>
+              <a:rPr lang="en-US" sz="900" dirty="0">
+                <a:solidFill>
                   <a:srgbClr val="77807A"/>
                 </a:solidFill>
                 <a:latin typeface="Arial" pitchFamily="34" charset="0"/>
                 <a:ea typeface="Arial" pitchFamily="34" charset="-122"/>
                 <a:cs typeface="Arial" pitchFamily="34" charset="-120"/>
               </a:rPr>
-              <a:t>Klassisches Haushaltsbuch</a:t>
-            </a:r>
-            <a:endParaRPr lang="en-US" sz="1100" dirty="0"/>
-          </a:p>
-        </p:txBody>
-      </p:sp>
-      <p:sp>
-        <p:nvSpPr>
-          <p:cNvPr id="6" name="Shape 4"/>
-          <p:cNvSpPr/>
-          <p:nvPr/>
-        </p:nvSpPr>
-        <p:spPr>
-          <a:xfrm>
-            <a:off x="5532120" y="1554480"/>
-            <a:ext cx="2743200" cy="0"/>
-          </a:xfrm>
-          <a:prstGeom prst="line">
-            <a:avLst/>
-          </a:prstGeom>
-          <a:noFill/>
-          <a:ln w="9525">
-            <a:solidFill>
-              <a:srgbClr val="E7E9E4"/>
-            </a:solidFill>
-            <a:prstDash val="solid"/>
-          </a:ln>
-        </p:spPr>
-      </p:sp>
-      <p:sp>
-        <p:nvSpPr>
-          <p:cNvPr id="7" name="Text 5"/>
-          <p:cNvSpPr/>
-          <p:nvPr/>
-        </p:nvSpPr>
-        <p:spPr>
-          <a:xfrm>
-            <a:off x="5532120" y="1645920"/>
-            <a:ext cx="1554480" cy="292608"/>
+              <a:t>2 × 1,29 €</a:t>
+            </a:r>
+            <a:endParaRPr lang="en-US" sz="900" dirty="0"/>
+          </a:p>
+        </p:txBody>
+      </p:sp>
+      <p:sp>
+        <p:nvSpPr>
+          <p:cNvPr id="13" name="Text 11"/>
+          <p:cNvSpPr/>
+          <p:nvPr/>
+        </p:nvSpPr>
+        <p:spPr>
+          <a:xfrm>
+            <a:off x="7498080" y="2587752"/>
+            <a:ext cx="777240" cy="256032"/>
           </a:xfrm>
           <a:prstGeom prst="rect">
             <a:avLst/>
@@ -1856,11 +2101,50 @@
           <a:bodyPr wrap="square" lIns="0" tIns="0" rIns="0" bIns="0" rtlCol="0" anchor="ctr"/>
           <a:lstStyle/>
           <a:p>
+            <a:pPr algn="r" indent="0" marL="0">
+              <a:buNone/>
+            </a:pPr>
+            <a:r>
+              <a:rPr lang="en-US" sz="1150" b="1" dirty="0">
+                <a:solidFill>
+                  <a:srgbClr val="12150F"/>
+                </a:solidFill>
+                <a:latin typeface="Arial" pitchFamily="34" charset="0"/>
+                <a:ea typeface="Arial" pitchFamily="34" charset="-122"/>
+                <a:cs typeface="Arial" pitchFamily="34" charset="-120"/>
+              </a:rPr>
+              <a:t>2,58 €</a:t>
+            </a:r>
+            <a:endParaRPr lang="en-US" sz="1150" dirty="0"/>
+          </a:p>
+        </p:txBody>
+      </p:sp>
+      <p:sp>
+        <p:nvSpPr>
+          <p:cNvPr id="14" name="Text 12"/>
+          <p:cNvSpPr/>
+          <p:nvPr/>
+        </p:nvSpPr>
+        <p:spPr>
+          <a:xfrm>
+            <a:off x="5120640" y="2944368"/>
+            <a:ext cx="2194560" cy="201168"/>
+          </a:xfrm>
+          <a:prstGeom prst="rect">
+            <a:avLst/>
+          </a:prstGeom>
+          <a:noFill/>
+          <a:ln/>
+        </p:spPr>
+        <p:txBody>
+          <a:bodyPr wrap="square" lIns="0" tIns="0" rIns="0" bIns="0" rtlCol="0" anchor="ctr"/>
+          <a:lstStyle/>
+          <a:p>
             <a:pPr indent="0" marL="0">
               <a:buNone/>
             </a:pPr>
             <a:r>
-              <a:rPr lang="en-US" sz="1200" b="1" dirty="0">
+              <a:rPr lang="en-US" sz="1150" b="1" dirty="0">
                 <a:solidFill>
                   <a:srgbClr val="12150F"/>
                 </a:solidFill>
@@ -1868,22 +2152,22 @@
                 <a:ea typeface="Arial" pitchFamily="34" charset="-122"/>
                 <a:cs typeface="Arial" pitchFamily="34" charset="-120"/>
               </a:rPr>
-              <a:t>REWE</a:t>
-            </a:r>
-            <a:endParaRPr lang="en-US" sz="1200" dirty="0"/>
-          </a:p>
-        </p:txBody>
-      </p:sp>
-      <p:sp>
-        <p:nvSpPr>
-          <p:cNvPr id="8" name="Text 6"/>
-          <p:cNvSpPr/>
-          <p:nvPr/>
-        </p:nvSpPr>
-        <p:spPr>
-          <a:xfrm>
-            <a:off x="7040880" y="1645920"/>
-            <a:ext cx="640080" cy="292608"/>
+              <a:t>Butter</a:t>
+            </a:r>
+            <a:endParaRPr lang="en-US" sz="1150" dirty="0"/>
+          </a:p>
+        </p:txBody>
+      </p:sp>
+      <p:sp>
+        <p:nvSpPr>
+          <p:cNvPr id="15" name="Text 13"/>
+          <p:cNvSpPr/>
+          <p:nvPr/>
+        </p:nvSpPr>
+        <p:spPr>
+          <a:xfrm>
+            <a:off x="5120640" y="3118104"/>
+            <a:ext cx="2194560" cy="182880"/>
           </a:xfrm>
           <a:prstGeom prst="rect">
             <a:avLst/>
@@ -1899,7 +2183,7 @@
               <a:buNone/>
             </a:pPr>
             <a:r>
-              <a:rPr lang="en-US" sz="1050" dirty="0">
+              <a:rPr lang="en-US" sz="900" dirty="0">
                 <a:solidFill>
                   <a:srgbClr val="77807A"/>
                 </a:solidFill>
@@ -1907,22 +2191,22 @@
                 <a:ea typeface="Arial" pitchFamily="34" charset="-122"/>
                 <a:cs typeface="Arial" pitchFamily="34" charset="-120"/>
               </a:rPr>
-              <a:t>02.08.</a:t>
-            </a:r>
-            <a:endParaRPr lang="en-US" sz="1050" dirty="0"/>
-          </a:p>
-        </p:txBody>
-      </p:sp>
-      <p:sp>
-        <p:nvSpPr>
-          <p:cNvPr id="9" name="Text 7"/>
-          <p:cNvSpPr/>
-          <p:nvPr/>
-        </p:nvSpPr>
-        <p:spPr>
-          <a:xfrm>
-            <a:off x="7315200" y="1645920"/>
-            <a:ext cx="960120" cy="292608"/>
+              <a:t>1 × 2,49 €</a:t>
+            </a:r>
+            <a:endParaRPr lang="en-US" sz="900" dirty="0"/>
+          </a:p>
+        </p:txBody>
+      </p:sp>
+      <p:sp>
+        <p:nvSpPr>
+          <p:cNvPr id="16" name="Text 14"/>
+          <p:cNvSpPr/>
+          <p:nvPr/>
+        </p:nvSpPr>
+        <p:spPr>
+          <a:xfrm>
+            <a:off x="7498080" y="2971800"/>
+            <a:ext cx="777240" cy="256032"/>
           </a:xfrm>
           <a:prstGeom prst="rect">
             <a:avLst/>
@@ -1938,7 +2222,7 @@
               <a:buNone/>
             </a:pPr>
             <a:r>
-              <a:rPr lang="en-US" sz="1200" b="1" dirty="0">
+              <a:rPr lang="en-US" sz="1150" b="1" dirty="0">
                 <a:solidFill>
                   <a:srgbClr val="12150F"/>
                 </a:solidFill>
@@ -1946,45 +2230,22 @@
                 <a:ea typeface="Arial" pitchFamily="34" charset="-122"/>
                 <a:cs typeface="Arial" pitchFamily="34" charset="-120"/>
               </a:rPr>
-              <a:t>45,73 €</a:t>
-            </a:r>
-            <a:endParaRPr lang="en-US" sz="1200" dirty="0"/>
-          </a:p>
-        </p:txBody>
-      </p:sp>
-      <p:sp>
-        <p:nvSpPr>
-          <p:cNvPr id="10" name="Shape 8"/>
-          <p:cNvSpPr/>
-          <p:nvPr/>
-        </p:nvSpPr>
-        <p:spPr>
-          <a:xfrm>
-            <a:off x="5532120" y="2011680"/>
-            <a:ext cx="2743200" cy="0"/>
-          </a:xfrm>
-          <a:prstGeom prst="line">
-            <a:avLst/>
-          </a:prstGeom>
-          <a:noFill/>
-          <a:ln w="9525">
-            <a:solidFill>
-              <a:srgbClr val="E7E9E4"/>
-            </a:solidFill>
-            <a:prstDash val="solid"/>
-          </a:ln>
-        </p:spPr>
-      </p:sp>
-      <p:sp>
-        <p:nvSpPr>
-          <p:cNvPr id="11" name="Text 9"/>
-          <p:cNvSpPr/>
-          <p:nvPr/>
-        </p:nvSpPr>
-        <p:spPr>
-          <a:xfrm>
-            <a:off x="5532120" y="2103120"/>
-            <a:ext cx="1554480" cy="292608"/>
+              <a:t>2,49 €</a:t>
+            </a:r>
+            <a:endParaRPr lang="en-US" sz="1150" dirty="0"/>
+          </a:p>
+        </p:txBody>
+      </p:sp>
+      <p:sp>
+        <p:nvSpPr>
+          <p:cNvPr id="17" name="Text 15"/>
+          <p:cNvSpPr/>
+          <p:nvPr/>
+        </p:nvSpPr>
+        <p:spPr>
+          <a:xfrm>
+            <a:off x="5120640" y="3328416"/>
+            <a:ext cx="2194560" cy="201168"/>
           </a:xfrm>
           <a:prstGeom prst="rect">
             <a:avLst/>
@@ -2000,7 +2261,7 @@
               <a:buNone/>
             </a:pPr>
             <a:r>
-              <a:rPr lang="en-US" sz="1200" b="1" dirty="0">
+              <a:rPr lang="en-US" sz="1150" b="1" dirty="0">
                 <a:solidFill>
                   <a:srgbClr val="12150F"/>
                 </a:solidFill>
@@ -2008,22 +2269,22 @@
                 <a:ea typeface="Arial" pitchFamily="34" charset="-122"/>
                 <a:cs typeface="Arial" pitchFamily="34" charset="-120"/>
               </a:rPr>
-              <a:t>ALDI SÜD</a:t>
-            </a:r>
-            <a:endParaRPr lang="en-US" sz="1200" dirty="0"/>
-          </a:p>
-        </p:txBody>
-      </p:sp>
-      <p:sp>
-        <p:nvSpPr>
-          <p:cNvPr id="12" name="Text 10"/>
-          <p:cNvSpPr/>
-          <p:nvPr/>
-        </p:nvSpPr>
-        <p:spPr>
-          <a:xfrm>
-            <a:off x="7040880" y="2103120"/>
-            <a:ext cx="640080" cy="292608"/>
+              <a:t>Bananen</a:t>
+            </a:r>
+            <a:endParaRPr lang="en-US" sz="1150" dirty="0"/>
+          </a:p>
+        </p:txBody>
+      </p:sp>
+      <p:sp>
+        <p:nvSpPr>
+          <p:cNvPr id="18" name="Text 16"/>
+          <p:cNvSpPr/>
+          <p:nvPr/>
+        </p:nvSpPr>
+        <p:spPr>
+          <a:xfrm>
+            <a:off x="5120640" y="3502152"/>
+            <a:ext cx="2194560" cy="182880"/>
           </a:xfrm>
           <a:prstGeom prst="rect">
             <a:avLst/>
@@ -2039,7 +2300,7 @@
               <a:buNone/>
             </a:pPr>
             <a:r>
-              <a:rPr lang="en-US" sz="1050" dirty="0">
+              <a:rPr lang="en-US" sz="900" dirty="0">
                 <a:solidFill>
                   <a:srgbClr val="77807A"/>
                 </a:solidFill>
@@ -2047,22 +2308,22 @@
                 <a:ea typeface="Arial" pitchFamily="34" charset="-122"/>
                 <a:cs typeface="Arial" pitchFamily="34" charset="-120"/>
               </a:rPr>
-              <a:t>26.07.</a:t>
-            </a:r>
-            <a:endParaRPr lang="en-US" sz="1050" dirty="0"/>
-          </a:p>
-        </p:txBody>
-      </p:sp>
-      <p:sp>
-        <p:nvSpPr>
-          <p:cNvPr id="13" name="Text 11"/>
-          <p:cNvSpPr/>
-          <p:nvPr/>
-        </p:nvSpPr>
-        <p:spPr>
-          <a:xfrm>
-            <a:off x="7315200" y="2103120"/>
-            <a:ext cx="960120" cy="292608"/>
+              <a:t>1,1 kg × 1,99 €/kg</a:t>
+            </a:r>
+            <a:endParaRPr lang="en-US" sz="900" dirty="0"/>
+          </a:p>
+        </p:txBody>
+      </p:sp>
+      <p:sp>
+        <p:nvSpPr>
+          <p:cNvPr id="19" name="Text 17"/>
+          <p:cNvSpPr/>
+          <p:nvPr/>
+        </p:nvSpPr>
+        <p:spPr>
+          <a:xfrm>
+            <a:off x="7498080" y="3355848"/>
+            <a:ext cx="777240" cy="256032"/>
           </a:xfrm>
           <a:prstGeom prst="rect">
             <a:avLst/>
@@ -2078,7 +2339,7 @@
               <a:buNone/>
             </a:pPr>
             <a:r>
-              <a:rPr lang="en-US" sz="1200" b="1" dirty="0">
+              <a:rPr lang="en-US" sz="1150" b="1" dirty="0">
                 <a:solidFill>
                   <a:srgbClr val="12150F"/>
                 </a:solidFill>
@@ -2086,45 +2347,22 @@
                 <a:ea typeface="Arial" pitchFamily="34" charset="-122"/>
                 <a:cs typeface="Arial" pitchFamily="34" charset="-120"/>
               </a:rPr>
-              <a:t>38,20 €</a:t>
-            </a:r>
-            <a:endParaRPr lang="en-US" sz="1200" dirty="0"/>
-          </a:p>
-        </p:txBody>
-      </p:sp>
-      <p:sp>
-        <p:nvSpPr>
-          <p:cNvPr id="14" name="Shape 12"/>
-          <p:cNvSpPr/>
-          <p:nvPr/>
-        </p:nvSpPr>
-        <p:spPr>
-          <a:xfrm>
-            <a:off x="5532120" y="2468880"/>
-            <a:ext cx="2743200" cy="0"/>
-          </a:xfrm>
-          <a:prstGeom prst="line">
-            <a:avLst/>
-          </a:prstGeom>
-          <a:noFill/>
-          <a:ln w="9525">
-            <a:solidFill>
-              <a:srgbClr val="E7E9E4"/>
-            </a:solidFill>
-            <a:prstDash val="solid"/>
-          </a:ln>
-        </p:spPr>
-      </p:sp>
-      <p:sp>
-        <p:nvSpPr>
-          <p:cNvPr id="15" name="Text 13"/>
-          <p:cNvSpPr/>
-          <p:nvPr/>
-        </p:nvSpPr>
-        <p:spPr>
-          <a:xfrm>
-            <a:off x="5532120" y="2560320"/>
-            <a:ext cx="1554480" cy="292608"/>
+              <a:t>2,19 €</a:t>
+            </a:r>
+            <a:endParaRPr lang="en-US" sz="1150" dirty="0"/>
+          </a:p>
+        </p:txBody>
+      </p:sp>
+      <p:sp>
+        <p:nvSpPr>
+          <p:cNvPr id="20" name="Text 18"/>
+          <p:cNvSpPr/>
+          <p:nvPr/>
+        </p:nvSpPr>
+        <p:spPr>
+          <a:xfrm>
+            <a:off x="5120640" y="3712464"/>
+            <a:ext cx="2194560" cy="201168"/>
           </a:xfrm>
           <a:prstGeom prst="rect">
             <a:avLst/>
@@ -2140,7 +2378,7 @@
               <a:buNone/>
             </a:pPr>
             <a:r>
-              <a:rPr lang="en-US" sz="1200" b="1" dirty="0">
+              <a:rPr lang="en-US" sz="1150" b="1" dirty="0">
                 <a:solidFill>
                   <a:srgbClr val="12150F"/>
                 </a:solidFill>
@@ -2148,22 +2386,22 @@
                 <a:ea typeface="Arial" pitchFamily="34" charset="-122"/>
                 <a:cs typeface="Arial" pitchFamily="34" charset="-120"/>
               </a:rPr>
-              <a:t>Edeka</a:t>
-            </a:r>
-            <a:endParaRPr lang="en-US" sz="1200" dirty="0"/>
-          </a:p>
-        </p:txBody>
-      </p:sp>
-      <p:sp>
-        <p:nvSpPr>
-          <p:cNvPr id="16" name="Text 14"/>
-          <p:cNvSpPr/>
-          <p:nvPr/>
-        </p:nvSpPr>
-        <p:spPr>
-          <a:xfrm>
-            <a:off x="7040880" y="2560320"/>
-            <a:ext cx="640080" cy="292608"/>
+              <a:t>Gouda am Stück</a:t>
+            </a:r>
+            <a:endParaRPr lang="en-US" sz="1150" dirty="0"/>
+          </a:p>
+        </p:txBody>
+      </p:sp>
+      <p:sp>
+        <p:nvSpPr>
+          <p:cNvPr id="21" name="Text 19"/>
+          <p:cNvSpPr/>
+          <p:nvPr/>
+        </p:nvSpPr>
+        <p:spPr>
+          <a:xfrm>
+            <a:off x="5120640" y="3886200"/>
+            <a:ext cx="2194560" cy="182880"/>
           </a:xfrm>
           <a:prstGeom prst="rect">
             <a:avLst/>
@@ -2179,7 +2417,7 @@
               <a:buNone/>
             </a:pPr>
             <a:r>
-              <a:rPr lang="en-US" sz="1050" dirty="0">
+              <a:rPr lang="en-US" sz="900" dirty="0">
                 <a:solidFill>
                   <a:srgbClr val="77807A"/>
                 </a:solidFill>
@@ -2187,22 +2425,22 @@
                 <a:ea typeface="Arial" pitchFamily="34" charset="-122"/>
                 <a:cs typeface="Arial" pitchFamily="34" charset="-120"/>
               </a:rPr>
-              <a:t>07.08.</a:t>
-            </a:r>
-            <a:endParaRPr lang="en-US" sz="1050" dirty="0"/>
-          </a:p>
-        </p:txBody>
-      </p:sp>
-      <p:sp>
-        <p:nvSpPr>
-          <p:cNvPr id="17" name="Text 15"/>
-          <p:cNvSpPr/>
-          <p:nvPr/>
-        </p:nvSpPr>
-        <p:spPr>
-          <a:xfrm>
-            <a:off x="7315200" y="2560320"/>
-            <a:ext cx="960120" cy="292608"/>
+              <a:t>0,32 kg × 12,90 €/kg</a:t>
+            </a:r>
+            <a:endParaRPr lang="en-US" sz="900" dirty="0"/>
+          </a:p>
+        </p:txBody>
+      </p:sp>
+      <p:sp>
+        <p:nvSpPr>
+          <p:cNvPr id="22" name="Text 20"/>
+          <p:cNvSpPr/>
+          <p:nvPr/>
+        </p:nvSpPr>
+        <p:spPr>
+          <a:xfrm>
+            <a:off x="7498080" y="3739896"/>
+            <a:ext cx="777240" cy="256032"/>
           </a:xfrm>
           <a:prstGeom prst="rect">
             <a:avLst/>
@@ -2218,7 +2456,7 @@
               <a:buNone/>
             </a:pPr>
             <a:r>
-              <a:rPr lang="en-US" sz="1200" b="1" dirty="0">
+              <a:rPr lang="en-US" sz="1150" b="1" dirty="0">
                 <a:solidFill>
                   <a:srgbClr val="12150F"/>
                 </a:solidFill>
@@ -2226,45 +2464,22 @@
                 <a:ea typeface="Arial" pitchFamily="34" charset="-122"/>
                 <a:cs typeface="Arial" pitchFamily="34" charset="-120"/>
               </a:rPr>
-              <a:t>15,47 €</a:t>
-            </a:r>
-            <a:endParaRPr lang="en-US" sz="1200" dirty="0"/>
-          </a:p>
-        </p:txBody>
-      </p:sp>
-      <p:sp>
-        <p:nvSpPr>
-          <p:cNvPr id="18" name="Shape 16"/>
-          <p:cNvSpPr/>
-          <p:nvPr/>
-        </p:nvSpPr>
-        <p:spPr>
-          <a:xfrm>
-            <a:off x="5532120" y="2926080"/>
-            <a:ext cx="2743200" cy="0"/>
-          </a:xfrm>
-          <a:prstGeom prst="line">
-            <a:avLst/>
-          </a:prstGeom>
-          <a:noFill/>
-          <a:ln w="9525">
-            <a:solidFill>
-              <a:srgbClr val="E7E9E4"/>
-            </a:solidFill>
-            <a:prstDash val="solid"/>
-          </a:ln>
-        </p:spPr>
-      </p:sp>
-      <p:sp>
-        <p:nvSpPr>
-          <p:cNvPr id="19" name="Text 17"/>
-          <p:cNvSpPr/>
-          <p:nvPr/>
-        </p:nvSpPr>
-        <p:spPr>
-          <a:xfrm>
-            <a:off x="5532120" y="3017520"/>
-            <a:ext cx="1554480" cy="292608"/>
+              <a:t>4,13 €</a:t>
+            </a:r>
+            <a:endParaRPr lang="en-US" sz="1150" dirty="0"/>
+          </a:p>
+        </p:txBody>
+      </p:sp>
+      <p:sp>
+        <p:nvSpPr>
+          <p:cNvPr id="23" name="Text 21"/>
+          <p:cNvSpPr/>
+          <p:nvPr/>
+        </p:nvSpPr>
+        <p:spPr>
+          <a:xfrm>
+            <a:off x="5120640" y="4187952"/>
+            <a:ext cx="3154680" cy="274320"/>
           </a:xfrm>
           <a:prstGeom prst="rect">
             <a:avLst/>
@@ -2280,46 +2495,7 @@
               <a:buNone/>
             </a:pPr>
             <a:r>
-              <a:rPr lang="en-US" sz="1200" b="1" dirty="0">
-                <a:solidFill>
-                  <a:srgbClr val="12150F"/>
-                </a:solidFill>
-                <a:latin typeface="Arial" pitchFamily="34" charset="0"/>
-                <a:ea typeface="Arial" pitchFamily="34" charset="-122"/>
-                <a:cs typeface="Arial" pitchFamily="34" charset="-120"/>
-              </a:rPr>
-              <a:t>Bäckerei Schmid</a:t>
-            </a:r>
-            <a:endParaRPr lang="en-US" sz="1200" dirty="0"/>
-          </a:p>
-        </p:txBody>
-      </p:sp>
-      <p:sp>
-        <p:nvSpPr>
-          <p:cNvPr id="20" name="Text 18"/>
-          <p:cNvSpPr/>
-          <p:nvPr/>
-        </p:nvSpPr>
-        <p:spPr>
-          <a:xfrm>
-            <a:off x="7040880" y="3017520"/>
-            <a:ext cx="640080" cy="292608"/>
-          </a:xfrm>
-          <a:prstGeom prst="rect">
-            <a:avLst/>
-          </a:prstGeom>
-          <a:noFill/>
-          <a:ln/>
-        </p:spPr>
-        <p:txBody>
-          <a:bodyPr wrap="square" lIns="0" tIns="0" rIns="0" bIns="0" rtlCol="0" anchor="ctr"/>
-          <a:lstStyle/>
-          <a:p>
-            <a:pPr indent="0" marL="0">
-              <a:buNone/>
-            </a:pPr>
-            <a:r>
-              <a:rPr lang="en-US" sz="1050" dirty="0">
+              <a:rPr lang="en-US" sz="1000" dirty="0">
                 <a:solidFill>
                   <a:srgbClr val="77807A"/>
                 </a:solidFill>
@@ -2327,87 +2503,9 @@
                 <a:ea typeface="Arial" pitchFamily="34" charset="-122"/>
                 <a:cs typeface="Arial" pitchFamily="34" charset="-120"/>
               </a:rPr>
-              <a:t>09.08.</a:t>
-            </a:r>
-            <a:endParaRPr lang="en-US" sz="1050" dirty="0"/>
-          </a:p>
-        </p:txBody>
-      </p:sp>
-      <p:sp>
-        <p:nvSpPr>
-          <p:cNvPr id="21" name="Text 19"/>
-          <p:cNvSpPr/>
-          <p:nvPr/>
-        </p:nvSpPr>
-        <p:spPr>
-          <a:xfrm>
-            <a:off x="7315200" y="3017520"/>
-            <a:ext cx="960120" cy="292608"/>
-          </a:xfrm>
-          <a:prstGeom prst="rect">
-            <a:avLst/>
-          </a:prstGeom>
-          <a:noFill/>
-          <a:ln/>
-        </p:spPr>
-        <p:txBody>
-          <a:bodyPr wrap="square" lIns="0" tIns="0" rIns="0" bIns="0" rtlCol="0" anchor="ctr"/>
-          <a:lstStyle/>
-          <a:p>
-            <a:pPr algn="r" indent="0" marL="0">
-              <a:buNone/>
-            </a:pPr>
-            <a:r>
-              <a:rPr lang="en-US" sz="1200" b="1" dirty="0">
-                <a:solidFill>
-                  <a:srgbClr val="12150F"/>
-                </a:solidFill>
-                <a:latin typeface="Arial" pitchFamily="34" charset="0"/>
-                <a:ea typeface="Arial" pitchFamily="34" charset="-122"/>
-                <a:cs typeface="Arial" pitchFamily="34" charset="-120"/>
-              </a:rPr>
-              <a:t>7,35 €</a:t>
-            </a:r>
-            <a:endParaRPr lang="en-US" sz="1200" dirty="0"/>
-          </a:p>
-        </p:txBody>
-      </p:sp>
-      <p:sp>
-        <p:nvSpPr>
-          <p:cNvPr id="22" name="Text 20"/>
-          <p:cNvSpPr/>
-          <p:nvPr/>
-        </p:nvSpPr>
-        <p:spPr>
-          <a:xfrm>
-            <a:off x="5532120" y="3383280"/>
-            <a:ext cx="2743200" cy="457200"/>
-          </a:xfrm>
-          <a:prstGeom prst="rect">
-            <a:avLst/>
-          </a:prstGeom>
-          <a:noFill/>
-          <a:ln/>
-        </p:spPr>
-        <p:txBody>
-          <a:bodyPr wrap="square" lIns="0" tIns="0" rIns="0" bIns="0" rtlCol="0" anchor="ctr"/>
-          <a:lstStyle/>
-          <a:p>
-            <a:pPr algn="ctr" indent="0" marL="0">
-              <a:buNone/>
-            </a:pPr>
-            <a:r>
-              <a:rPr lang="en-US" sz="1500" b="1" dirty="0">
-                <a:solidFill>
-                  <a:srgbClr val="77807A"/>
-                </a:solidFill>
-                <a:latin typeface="Arial" pitchFamily="34" charset="0"/>
-                <a:ea typeface="Arial" pitchFamily="34" charset="-122"/>
-                <a:cs typeface="Arial" pitchFamily="34" charset="-120"/>
-              </a:rPr>
-              <a:t>… und wofür?</a:t>
-            </a:r>
-            <a:endParaRPr lang="en-US" sz="1500" dirty="0"/>
+              <a:t>… und fünf weitere Positionen desselben Bons</a:t>
+            </a:r>
+            <a:endParaRPr lang="en-US" sz="1000" dirty="0"/>
           </a:p>
         </p:txBody>
       </p:sp>
@@ -2922,8 +3020,8 @@
         </p:nvSpPr>
         <p:spPr>
           <a:xfrm>
-            <a:off x="594360" y="4668012"/>
-            <a:ext cx="4937760" cy="274320"/>
+            <a:off x="594360" y="4640580"/>
+            <a:ext cx="3657600" cy="274320"/>
           </a:xfrm>
           <a:prstGeom prst="rect">
             <a:avLst/>
@@ -2987,14 +3085,72 @@
       </p:grpSpPr>
       <p:sp>
         <p:nvSpPr>
-          <p:cNvPr id="2" name="Text 0"/>
-          <p:cNvSpPr/>
-          <p:nvPr/>
-        </p:nvSpPr>
-        <p:spPr>
-          <a:xfrm>
-            <a:off x="594360" y="457200"/>
-            <a:ext cx="7955280" cy="1005840"/>
+          <p:cNvPr id="2" name="Shape 0"/>
+          <p:cNvSpPr/>
+          <p:nvPr/>
+        </p:nvSpPr>
+        <p:spPr>
+          <a:xfrm>
+            <a:off x="694944" y="409194"/>
+            <a:ext cx="1936547" cy="4434840"/>
+          </a:xfrm>
+          <a:prstGeom prst="roundRect">
+            <a:avLst>
+              <a:gd name="adj" fmla="val 9444"/>
+            </a:avLst>
+          </a:prstGeom>
+          <a:solidFill>
+            <a:srgbClr val="FFFFFF"/>
+          </a:solidFill>
+          <a:ln w="3175">
+            <a:solidFill>
+              <a:srgbClr val="FFFFFF"/>
+            </a:solidFill>
+            <a:prstDash val="solid"/>
+          </a:ln>
+          <a:effectLst>
+            <a:outerShdw sx="100000" sy="100000" kx="0" ky="0" algn="bl" rotWithShape="0" blurRad="279400" dist="63500" dir="5400000">
+              <a:srgbClr val="000000">
+                <a:alpha val="16000"/>
+              </a:srgbClr>
+            </a:outerShdw>
+          </a:effectLst>
+        </p:spPr>
+      </p:sp>
+      <p:pic>
+        <p:nvPicPr>
+          <p:cNvPr id="3" name="Image 0" descr="/var/tmp/deck/img/uebersicht.png">    </p:cNvPr>
+          <p:cNvPicPr>
+            <a:picLocks noChangeAspect="1"/>
+          </p:cNvPicPr>
+          <p:nvPr/>
+        </p:nvPicPr>
+        <p:blipFill>
+          <a:blip r:embed="rId1"/>
+          <a:stretch>
+            <a:fillRect/>
+          </a:stretch>
+        </p:blipFill>
+        <p:spPr>
+          <a:xfrm>
+            <a:off x="658368" y="354330"/>
+            <a:ext cx="1936547" cy="4434840"/>
+          </a:xfrm>
+          <a:prstGeom prst="rect">
+            <a:avLst/>
+          </a:prstGeom>
+        </p:spPr>
+      </p:pic>
+      <p:sp>
+        <p:nvSpPr>
+          <p:cNvPr id="4" name="Text 1"/>
+          <p:cNvSpPr/>
+          <p:nvPr/>
+        </p:nvSpPr>
+        <p:spPr>
+          <a:xfrm>
+            <a:off x="3280715" y="1417320"/>
+            <a:ext cx="5223205" cy="1005840"/>
           </a:xfrm>
           <a:prstGeom prst="rect">
             <a:avLst/>
@@ -3013,7 +3169,7 @@
               <a:buNone/>
             </a:pPr>
             <a:r>
-              <a:rPr lang="en-US" sz="2800" b="1" dirty="0">
+              <a:rPr lang="en-US" sz="3000" b="1" dirty="0">
                 <a:solidFill>
                   <a:srgbClr val="12150F"/>
                 </a:solidFill>
@@ -3021,42 +3177,22 @@
                 <a:ea typeface="Arial" pitchFamily="34" charset="-122"/>
                 <a:cs typeface="Arial" pitchFamily="34" charset="-120"/>
               </a:rPr>
-              <a:t>Nicht „27 € bei REWE“.</a:t>
-            </a:r>
-            <a:endParaRPr lang="en-US" sz="2800" dirty="0"/>
-          </a:p>
-          <a:p>
-            <a:pPr algn="l" indent="0" marL="0">
-              <a:lnSpc>
-                <a:spcPct val="105000"/>
-              </a:lnSpc>
-              <a:buNone/>
-            </a:pPr>
-            <a:r>
-              <a:rPr lang="en-US" sz="2800" b="1" dirty="0">
-                <a:solidFill>
-                  <a:srgbClr val="12150F"/>
-                </a:solidFill>
-                <a:latin typeface="Arial" pitchFamily="34" charset="0"/>
-                <a:ea typeface="Arial" pitchFamily="34" charset="-122"/>
-                <a:cs typeface="Arial" pitchFamily="34" charset="-120"/>
-              </a:rPr>
-              <a:t>Sondern jede Position.</a:t>
-            </a:r>
-            <a:endParaRPr lang="en-US" sz="2800" dirty="0"/>
-          </a:p>
-        </p:txBody>
-      </p:sp>
-      <p:sp>
-        <p:nvSpPr>
-          <p:cNvPr id="3" name="Text 1"/>
-          <p:cNvSpPr/>
-          <p:nvPr/>
-        </p:nvSpPr>
-        <p:spPr>
-          <a:xfrm>
-            <a:off x="594360" y="1572768"/>
-            <a:ext cx="7955280" cy="731520"/>
+              <a:t>Der Monat auf einen Blick.</a:t>
+            </a:r>
+            <a:endParaRPr lang="en-US" sz="3000" dirty="0"/>
+          </a:p>
+        </p:txBody>
+      </p:sp>
+      <p:sp>
+        <p:nvSpPr>
+          <p:cNvPr id="5" name="Text 2"/>
+          <p:cNvSpPr/>
+          <p:nvPr/>
+        </p:nvSpPr>
+        <p:spPr>
+          <a:xfrm>
+            <a:off x="3280715" y="2377440"/>
+            <a:ext cx="5223205" cy="1463040"/>
           </a:xfrm>
           <a:prstGeom prst="rect">
             <a:avLst/>
@@ -3075,7 +3211,7 @@
               <a:buNone/>
             </a:pPr>
             <a:r>
-              <a:rPr lang="en-US" sz="1350" dirty="0">
+              <a:rPr lang="en-US" sz="1400" dirty="0">
                 <a:solidFill>
                   <a:srgbClr val="77807A"/>
                 </a:solidFill>
@@ -3083,56 +3219,22 @@
                 <a:ea typeface="Arial" pitchFamily="34" charset="-122"/>
                 <a:cs typeface="Arial" pitchFamily="34" charset="-120"/>
               </a:rPr>
-              <a:t>Weil jede Zeile einzeln gespeichert wird, werden Fragen beantwortbar, die sonst niemand beantwortet: Wie viel gebe ich im Jahr für Käse aus? Ist meine Butter teurer geworden?</a:t>
-            </a:r>
-            <a:endParaRPr lang="en-US" sz="1350" dirty="0"/>
-          </a:p>
-        </p:txBody>
-      </p:sp>
-      <p:sp>
-        <p:nvSpPr>
-          <p:cNvPr id="4" name="Shape 2"/>
-          <p:cNvSpPr/>
-          <p:nvPr/>
-        </p:nvSpPr>
-        <p:spPr>
-          <a:xfrm>
-            <a:off x="594360" y="2240280"/>
-            <a:ext cx="3200400" cy="2377440"/>
-          </a:xfrm>
-          <a:prstGeom prst="roundRect">
-            <a:avLst>
-              <a:gd name="adj" fmla="val 6154"/>
-            </a:avLst>
-          </a:prstGeom>
-          <a:solidFill>
-            <a:srgbClr val="FAFAF8"/>
-          </a:solidFill>
-          <a:ln w="9525">
-            <a:solidFill>
-              <a:srgbClr val="E7E9E4"/>
-            </a:solidFill>
-            <a:prstDash val="solid"/>
-          </a:ln>
-          <a:effectLst>
-            <a:outerShdw sx="100000" sy="100000" kx="0" ky="0" algn="bl" rotWithShape="0" blurRad="177800" dist="38100" dir="5400000">
-              <a:srgbClr val="000000">
-                <a:alpha val="10000"/>
-              </a:srgbClr>
-            </a:outerShdw>
-          </a:effectLst>
-        </p:spPr>
-      </p:sp>
-      <p:sp>
-        <p:nvSpPr>
-          <p:cNvPr id="5" name="Text 3"/>
-          <p:cNvSpPr/>
-          <p:nvPr/>
-        </p:nvSpPr>
-        <p:spPr>
-          <a:xfrm>
-            <a:off x="868680" y="2496312"/>
-            <a:ext cx="2651760" cy="274320"/>
+              <a:t>Was bisher zusammengekommen ist, wie viel vom Budget noch übrig ist – und wohin das Geld geflossen ist. Die Hochrechnung sagt, wo der Monat endet, wenn es so weitergeht wie bisher.</a:t>
+            </a:r>
+            <a:endParaRPr lang="en-US" sz="1400" dirty="0"/>
+          </a:p>
+        </p:txBody>
+      </p:sp>
+      <p:sp>
+        <p:nvSpPr>
+          <p:cNvPr id="6" name="Text 3"/>
+          <p:cNvSpPr/>
+          <p:nvPr/>
+        </p:nvSpPr>
+        <p:spPr>
+          <a:xfrm>
+            <a:off x="3280715" y="4640580"/>
+            <a:ext cx="3657600" cy="274320"/>
           </a:xfrm>
           <a:prstGeom prst="rect">
             <a:avLst/>
@@ -3144,11 +3246,11 @@
           <a:bodyPr wrap="square" lIns="0" tIns="0" rIns="0" bIns="0" rtlCol="0" anchor="ctr"/>
           <a:lstStyle/>
           <a:p>
-            <a:pPr indent="0" marL="0">
-              <a:buNone/>
-            </a:pPr>
-            <a:r>
-              <a:rPr lang="en-US" sz="1100" b="1" dirty="0">
+            <a:pPr algn="l" indent="0" marL="0">
+              <a:buNone/>
+            </a:pPr>
+            <a:r>
+              <a:rPr lang="en-US" sz="900" dirty="0">
                 <a:solidFill>
                   <a:srgbClr val="77807A"/>
                 </a:solidFill>
@@ -3156,706 +3258,9 @@
                 <a:ea typeface="Arial" pitchFamily="34" charset="-122"/>
                 <a:cs typeface="Arial" pitchFamily="34" charset="-120"/>
               </a:rPr>
-              <a:t>Andere Apps speichern</a:t>
-            </a:r>
-            <a:endParaRPr lang="en-US" sz="1100" dirty="0"/>
-          </a:p>
-        </p:txBody>
-      </p:sp>
-      <p:sp>
-        <p:nvSpPr>
-          <p:cNvPr id="6" name="Text 4"/>
-          <p:cNvSpPr/>
-          <p:nvPr/>
-        </p:nvSpPr>
-        <p:spPr>
-          <a:xfrm>
-            <a:off x="868680" y="3108960"/>
-            <a:ext cx="2651760" cy="365760"/>
-          </a:xfrm>
-          <a:prstGeom prst="rect">
-            <a:avLst/>
-          </a:prstGeom>
-          <a:noFill/>
-          <a:ln/>
-        </p:spPr>
-        <p:txBody>
-          <a:bodyPr wrap="square" lIns="0" tIns="0" rIns="0" bIns="0" rtlCol="0" anchor="ctr"/>
-          <a:lstStyle/>
-          <a:p>
-            <a:pPr indent="0" marL="0">
-              <a:buNone/>
-            </a:pPr>
-            <a:r>
-              <a:rPr lang="en-US" sz="1700" b="1" dirty="0">
-                <a:solidFill>
-                  <a:srgbClr val="12150F"/>
-                </a:solidFill>
-                <a:latin typeface="Arial" pitchFamily="34" charset="0"/>
-                <a:ea typeface="Arial" pitchFamily="34" charset="-122"/>
-                <a:cs typeface="Arial" pitchFamily="34" charset="-120"/>
-              </a:rPr>
-              <a:t>REWE</a:t>
-            </a:r>
-            <a:endParaRPr lang="en-US" sz="1700" dirty="0"/>
-          </a:p>
-        </p:txBody>
-      </p:sp>
-      <p:sp>
-        <p:nvSpPr>
-          <p:cNvPr id="7" name="Text 5"/>
-          <p:cNvSpPr/>
-          <p:nvPr/>
-        </p:nvSpPr>
-        <p:spPr>
-          <a:xfrm>
-            <a:off x="868680" y="3493008"/>
-            <a:ext cx="2651760" cy="274320"/>
-          </a:xfrm>
-          <a:prstGeom prst="rect">
-            <a:avLst/>
-          </a:prstGeom>
-          <a:noFill/>
-          <a:ln/>
-        </p:spPr>
-        <p:txBody>
-          <a:bodyPr wrap="square" lIns="0" tIns="0" rIns="0" bIns="0" rtlCol="0" anchor="ctr"/>
-          <a:lstStyle/>
-          <a:p>
-            <a:pPr indent="0" marL="0">
-              <a:buNone/>
-            </a:pPr>
-            <a:r>
-              <a:rPr lang="en-US" sz="1100" dirty="0">
-                <a:solidFill>
-                  <a:srgbClr val="77807A"/>
-                </a:solidFill>
-                <a:latin typeface="Arial" pitchFamily="34" charset="0"/>
-                <a:ea typeface="Arial" pitchFamily="34" charset="-122"/>
-                <a:cs typeface="Arial" pitchFamily="34" charset="-120"/>
-              </a:rPr>
-              <a:t>02.08.2026</a:t>
-            </a:r>
-            <a:endParaRPr lang="en-US" sz="1100" dirty="0"/>
-          </a:p>
-        </p:txBody>
-      </p:sp>
-      <p:sp>
-        <p:nvSpPr>
-          <p:cNvPr id="8" name="Text 6"/>
-          <p:cNvSpPr/>
-          <p:nvPr/>
-        </p:nvSpPr>
-        <p:spPr>
-          <a:xfrm>
-            <a:off x="868680" y="3813048"/>
-            <a:ext cx="2651760" cy="457200"/>
-          </a:xfrm>
-          <a:prstGeom prst="rect">
-            <a:avLst/>
-          </a:prstGeom>
-          <a:noFill/>
-          <a:ln/>
-        </p:spPr>
-        <p:txBody>
-          <a:bodyPr wrap="square" lIns="0" tIns="0" rIns="0" bIns="0" rtlCol="0" anchor="ctr"/>
-          <a:lstStyle/>
-          <a:p>
-            <a:pPr indent="0" marL="0">
-              <a:buNone/>
-            </a:pPr>
-            <a:r>
-              <a:rPr lang="en-US" sz="2400" b="1" dirty="0">
-                <a:solidFill>
-                  <a:srgbClr val="12150F"/>
-                </a:solidFill>
-                <a:latin typeface="Arial" pitchFamily="34" charset="0"/>
-                <a:ea typeface="Arial" pitchFamily="34" charset="-122"/>
-                <a:cs typeface="Arial" pitchFamily="34" charset="-120"/>
-              </a:rPr>
-              <a:t>27,31 €</a:t>
-            </a:r>
-            <a:endParaRPr lang="en-US" sz="2400" dirty="0"/>
-          </a:p>
-        </p:txBody>
-      </p:sp>
-      <p:sp>
-        <p:nvSpPr>
-          <p:cNvPr id="9" name="Shape 7"/>
-          <p:cNvSpPr/>
-          <p:nvPr/>
-        </p:nvSpPr>
-        <p:spPr>
-          <a:xfrm>
-            <a:off x="4160520" y="2240280"/>
-            <a:ext cx="4389120" cy="2377440"/>
-          </a:xfrm>
-          <a:prstGeom prst="roundRect">
-            <a:avLst>
-              <a:gd name="adj" fmla="val 6154"/>
-            </a:avLst>
-          </a:prstGeom>
-          <a:solidFill>
-            <a:srgbClr val="FFFFFF"/>
-          </a:solidFill>
-          <a:ln w="9525">
-            <a:solidFill>
-              <a:srgbClr val="E7E9E4"/>
-            </a:solidFill>
-            <a:prstDash val="solid"/>
-          </a:ln>
-          <a:effectLst>
-            <a:outerShdw sx="100000" sy="100000" kx="0" ky="0" algn="bl" rotWithShape="0" blurRad="177800" dist="38100" dir="5400000">
-              <a:srgbClr val="000000">
-                <a:alpha val="10000"/>
-              </a:srgbClr>
-            </a:outerShdw>
-          </a:effectLst>
-        </p:spPr>
-      </p:sp>
-      <p:sp>
-        <p:nvSpPr>
-          <p:cNvPr id="10" name="Text 8"/>
-          <p:cNvSpPr/>
-          <p:nvPr/>
-        </p:nvSpPr>
-        <p:spPr>
-          <a:xfrm>
-            <a:off x="4434840" y="2496312"/>
-            <a:ext cx="3840480" cy="274320"/>
-          </a:xfrm>
-          <a:prstGeom prst="rect">
-            <a:avLst/>
-          </a:prstGeom>
-          <a:noFill/>
-          <a:ln/>
-        </p:spPr>
-        <p:txBody>
-          <a:bodyPr wrap="square" lIns="0" tIns="0" rIns="0" bIns="0" rtlCol="0" anchor="ctr"/>
-          <a:lstStyle/>
-          <a:p>
-            <a:pPr indent="0" marL="0">
-              <a:buNone/>
-            </a:pPr>
-            <a:r>
-              <a:rPr lang="en-US" sz="1100" b="1" dirty="0">
-                <a:solidFill>
-                  <a:srgbClr val="16915C"/>
-                </a:solidFill>
-                <a:latin typeface="Arial" pitchFamily="34" charset="0"/>
-                <a:ea typeface="Arial" pitchFamily="34" charset="-122"/>
-                <a:cs typeface="Arial" pitchFamily="34" charset="-120"/>
-              </a:rPr>
-              <a:t>Receipt AI speichert</a:t>
-            </a:r>
-            <a:endParaRPr lang="en-US" sz="1100" dirty="0"/>
-          </a:p>
-        </p:txBody>
-      </p:sp>
-      <p:sp>
-        <p:nvSpPr>
-          <p:cNvPr id="11" name="Text 9"/>
-          <p:cNvSpPr/>
-          <p:nvPr/>
-        </p:nvSpPr>
-        <p:spPr>
-          <a:xfrm>
-            <a:off x="4434840" y="2862072"/>
-            <a:ext cx="1737360" cy="292608"/>
-          </a:xfrm>
-          <a:prstGeom prst="rect">
-            <a:avLst/>
-          </a:prstGeom>
-          <a:noFill/>
-          <a:ln/>
-        </p:spPr>
-        <p:txBody>
-          <a:bodyPr wrap="square" lIns="0" tIns="0" rIns="0" bIns="0" rtlCol="0" anchor="ctr"/>
-          <a:lstStyle/>
-          <a:p>
-            <a:pPr indent="0" marL="0">
-              <a:buNone/>
-            </a:pPr>
-            <a:r>
-              <a:rPr lang="en-US" sz="1150" b="1" dirty="0">
-                <a:solidFill>
-                  <a:srgbClr val="12150F"/>
-                </a:solidFill>
-                <a:latin typeface="Arial" pitchFamily="34" charset="0"/>
-                <a:ea typeface="Arial" pitchFamily="34" charset="-122"/>
-                <a:cs typeface="Arial" pitchFamily="34" charset="-120"/>
-              </a:rPr>
-              <a:t>H-Milch 1,5 %</a:t>
-            </a:r>
-            <a:endParaRPr lang="en-US" sz="1150" dirty="0"/>
-          </a:p>
-        </p:txBody>
-      </p:sp>
-      <p:sp>
-        <p:nvSpPr>
-          <p:cNvPr id="12" name="Text 10"/>
-          <p:cNvSpPr/>
-          <p:nvPr/>
-        </p:nvSpPr>
-        <p:spPr>
-          <a:xfrm>
-            <a:off x="6172200" y="2862072"/>
-            <a:ext cx="1508760" cy="292608"/>
-          </a:xfrm>
-          <a:prstGeom prst="rect">
-            <a:avLst/>
-          </a:prstGeom>
-          <a:noFill/>
-          <a:ln/>
-        </p:spPr>
-        <p:txBody>
-          <a:bodyPr wrap="square" lIns="0" tIns="0" rIns="0" bIns="0" rtlCol="0" anchor="ctr"/>
-          <a:lstStyle/>
-          <a:p>
-            <a:pPr indent="0" marL="0">
-              <a:buNone/>
-            </a:pPr>
-            <a:r>
-              <a:rPr lang="en-US" sz="1000" dirty="0">
-                <a:solidFill>
-                  <a:srgbClr val="77807A"/>
-                </a:solidFill>
-                <a:latin typeface="Arial" pitchFamily="34" charset="0"/>
-                <a:ea typeface="Arial" pitchFamily="34" charset="-122"/>
-                <a:cs typeface="Arial" pitchFamily="34" charset="-120"/>
-              </a:rPr>
-              <a:t>2 × 1,29 €</a:t>
-            </a:r>
-            <a:endParaRPr lang="en-US" sz="1000" dirty="0"/>
-          </a:p>
-        </p:txBody>
-      </p:sp>
-      <p:sp>
-        <p:nvSpPr>
-          <p:cNvPr id="13" name="Text 11"/>
-          <p:cNvSpPr/>
-          <p:nvPr/>
-        </p:nvSpPr>
-        <p:spPr>
-          <a:xfrm>
-            <a:off x="7589520" y="2862072"/>
-            <a:ext cx="685800" cy="292608"/>
-          </a:xfrm>
-          <a:prstGeom prst="rect">
-            <a:avLst/>
-          </a:prstGeom>
-          <a:noFill/>
-          <a:ln/>
-        </p:spPr>
-        <p:txBody>
-          <a:bodyPr wrap="square" lIns="0" tIns="0" rIns="0" bIns="0" rtlCol="0" anchor="ctr"/>
-          <a:lstStyle/>
-          <a:p>
-            <a:pPr algn="r" indent="0" marL="0">
-              <a:buNone/>
-            </a:pPr>
-            <a:r>
-              <a:rPr lang="en-US" sz="1150" b="1" dirty="0">
-                <a:solidFill>
-                  <a:srgbClr val="12150F"/>
-                </a:solidFill>
-                <a:latin typeface="Arial" pitchFamily="34" charset="0"/>
-                <a:ea typeface="Arial" pitchFamily="34" charset="-122"/>
-                <a:cs typeface="Arial" pitchFamily="34" charset="-120"/>
-              </a:rPr>
-              <a:t>2,58 €</a:t>
-            </a:r>
-            <a:endParaRPr lang="en-US" sz="1150" dirty="0"/>
-          </a:p>
-        </p:txBody>
-      </p:sp>
-      <p:sp>
-        <p:nvSpPr>
-          <p:cNvPr id="14" name="Text 12"/>
-          <p:cNvSpPr/>
-          <p:nvPr/>
-        </p:nvSpPr>
-        <p:spPr>
-          <a:xfrm>
-            <a:off x="4434840" y="3191256"/>
-            <a:ext cx="1737360" cy="292608"/>
-          </a:xfrm>
-          <a:prstGeom prst="rect">
-            <a:avLst/>
-          </a:prstGeom>
-          <a:noFill/>
-          <a:ln/>
-        </p:spPr>
-        <p:txBody>
-          <a:bodyPr wrap="square" lIns="0" tIns="0" rIns="0" bIns="0" rtlCol="0" anchor="ctr"/>
-          <a:lstStyle/>
-          <a:p>
-            <a:pPr indent="0" marL="0">
-              <a:buNone/>
-            </a:pPr>
-            <a:r>
-              <a:rPr lang="en-US" sz="1150" b="1" dirty="0">
-                <a:solidFill>
-                  <a:srgbClr val="12150F"/>
-                </a:solidFill>
-                <a:latin typeface="Arial" pitchFamily="34" charset="0"/>
-                <a:ea typeface="Arial" pitchFamily="34" charset="-122"/>
-                <a:cs typeface="Arial" pitchFamily="34" charset="-120"/>
-              </a:rPr>
-              <a:t>Butter</a:t>
-            </a:r>
-            <a:endParaRPr lang="en-US" sz="1150" dirty="0"/>
-          </a:p>
-        </p:txBody>
-      </p:sp>
-      <p:sp>
-        <p:nvSpPr>
-          <p:cNvPr id="15" name="Text 13"/>
-          <p:cNvSpPr/>
-          <p:nvPr/>
-        </p:nvSpPr>
-        <p:spPr>
-          <a:xfrm>
-            <a:off x="6172200" y="3191256"/>
-            <a:ext cx="1508760" cy="292608"/>
-          </a:xfrm>
-          <a:prstGeom prst="rect">
-            <a:avLst/>
-          </a:prstGeom>
-          <a:noFill/>
-          <a:ln/>
-        </p:spPr>
-        <p:txBody>
-          <a:bodyPr wrap="square" lIns="0" tIns="0" rIns="0" bIns="0" rtlCol="0" anchor="ctr"/>
-          <a:lstStyle/>
-          <a:p>
-            <a:pPr indent="0" marL="0">
-              <a:buNone/>
-            </a:pPr>
-            <a:r>
-              <a:rPr lang="en-US" sz="1000" dirty="0">
-                <a:solidFill>
-                  <a:srgbClr val="77807A"/>
-                </a:solidFill>
-                <a:latin typeface="Arial" pitchFamily="34" charset="0"/>
-                <a:ea typeface="Arial" pitchFamily="34" charset="-122"/>
-                <a:cs typeface="Arial" pitchFamily="34" charset="-120"/>
-              </a:rPr>
-              <a:t>1 × 2,49 €</a:t>
-            </a:r>
-            <a:endParaRPr lang="en-US" sz="1000" dirty="0"/>
-          </a:p>
-        </p:txBody>
-      </p:sp>
-      <p:sp>
-        <p:nvSpPr>
-          <p:cNvPr id="16" name="Text 14"/>
-          <p:cNvSpPr/>
-          <p:nvPr/>
-        </p:nvSpPr>
-        <p:spPr>
-          <a:xfrm>
-            <a:off x="7589520" y="3191256"/>
-            <a:ext cx="685800" cy="292608"/>
-          </a:xfrm>
-          <a:prstGeom prst="rect">
-            <a:avLst/>
-          </a:prstGeom>
-          <a:noFill/>
-          <a:ln/>
-        </p:spPr>
-        <p:txBody>
-          <a:bodyPr wrap="square" lIns="0" tIns="0" rIns="0" bIns="0" rtlCol="0" anchor="ctr"/>
-          <a:lstStyle/>
-          <a:p>
-            <a:pPr algn="r" indent="0" marL="0">
-              <a:buNone/>
-            </a:pPr>
-            <a:r>
-              <a:rPr lang="en-US" sz="1150" b="1" dirty="0">
-                <a:solidFill>
-                  <a:srgbClr val="12150F"/>
-                </a:solidFill>
-                <a:latin typeface="Arial" pitchFamily="34" charset="0"/>
-                <a:ea typeface="Arial" pitchFamily="34" charset="-122"/>
-                <a:cs typeface="Arial" pitchFamily="34" charset="-120"/>
-              </a:rPr>
-              <a:t>2,49 €</a:t>
-            </a:r>
-            <a:endParaRPr lang="en-US" sz="1150" dirty="0"/>
-          </a:p>
-        </p:txBody>
-      </p:sp>
-      <p:sp>
-        <p:nvSpPr>
-          <p:cNvPr id="17" name="Text 15"/>
-          <p:cNvSpPr/>
-          <p:nvPr/>
-        </p:nvSpPr>
-        <p:spPr>
-          <a:xfrm>
-            <a:off x="4434840" y="3520440"/>
-            <a:ext cx="1737360" cy="292608"/>
-          </a:xfrm>
-          <a:prstGeom prst="rect">
-            <a:avLst/>
-          </a:prstGeom>
-          <a:noFill/>
-          <a:ln/>
-        </p:spPr>
-        <p:txBody>
-          <a:bodyPr wrap="square" lIns="0" tIns="0" rIns="0" bIns="0" rtlCol="0" anchor="ctr"/>
-          <a:lstStyle/>
-          <a:p>
-            <a:pPr indent="0" marL="0">
-              <a:buNone/>
-            </a:pPr>
-            <a:r>
-              <a:rPr lang="en-US" sz="1150" b="1" dirty="0">
-                <a:solidFill>
-                  <a:srgbClr val="12150F"/>
-                </a:solidFill>
-                <a:latin typeface="Arial" pitchFamily="34" charset="0"/>
-                <a:ea typeface="Arial" pitchFamily="34" charset="-122"/>
-                <a:cs typeface="Arial" pitchFamily="34" charset="-120"/>
-              </a:rPr>
-              <a:t>Bananen</a:t>
-            </a:r>
-            <a:endParaRPr lang="en-US" sz="1150" dirty="0"/>
-          </a:p>
-        </p:txBody>
-      </p:sp>
-      <p:sp>
-        <p:nvSpPr>
-          <p:cNvPr id="18" name="Text 16"/>
-          <p:cNvSpPr/>
-          <p:nvPr/>
-        </p:nvSpPr>
-        <p:spPr>
-          <a:xfrm>
-            <a:off x="6172200" y="3520440"/>
-            <a:ext cx="1508760" cy="292608"/>
-          </a:xfrm>
-          <a:prstGeom prst="rect">
-            <a:avLst/>
-          </a:prstGeom>
-          <a:noFill/>
-          <a:ln/>
-        </p:spPr>
-        <p:txBody>
-          <a:bodyPr wrap="square" lIns="0" tIns="0" rIns="0" bIns="0" rtlCol="0" anchor="ctr"/>
-          <a:lstStyle/>
-          <a:p>
-            <a:pPr indent="0" marL="0">
-              <a:buNone/>
-            </a:pPr>
-            <a:r>
-              <a:rPr lang="en-US" sz="1000" dirty="0">
-                <a:solidFill>
-                  <a:srgbClr val="77807A"/>
-                </a:solidFill>
-                <a:latin typeface="Arial" pitchFamily="34" charset="0"/>
-                <a:ea typeface="Arial" pitchFamily="34" charset="-122"/>
-                <a:cs typeface="Arial" pitchFamily="34" charset="-120"/>
-              </a:rPr>
-              <a:t>1,1 kg × 1,99 €/kg</a:t>
-            </a:r>
-            <a:endParaRPr lang="en-US" sz="1000" dirty="0"/>
-          </a:p>
-        </p:txBody>
-      </p:sp>
-      <p:sp>
-        <p:nvSpPr>
-          <p:cNvPr id="19" name="Text 17"/>
-          <p:cNvSpPr/>
-          <p:nvPr/>
-        </p:nvSpPr>
-        <p:spPr>
-          <a:xfrm>
-            <a:off x="7589520" y="3520440"/>
-            <a:ext cx="685800" cy="292608"/>
-          </a:xfrm>
-          <a:prstGeom prst="rect">
-            <a:avLst/>
-          </a:prstGeom>
-          <a:noFill/>
-          <a:ln/>
-        </p:spPr>
-        <p:txBody>
-          <a:bodyPr wrap="square" lIns="0" tIns="0" rIns="0" bIns="0" rtlCol="0" anchor="ctr"/>
-          <a:lstStyle/>
-          <a:p>
-            <a:pPr algn="r" indent="0" marL="0">
-              <a:buNone/>
-            </a:pPr>
-            <a:r>
-              <a:rPr lang="en-US" sz="1150" b="1" dirty="0">
-                <a:solidFill>
-                  <a:srgbClr val="12150F"/>
-                </a:solidFill>
-                <a:latin typeface="Arial" pitchFamily="34" charset="0"/>
-                <a:ea typeface="Arial" pitchFamily="34" charset="-122"/>
-                <a:cs typeface="Arial" pitchFamily="34" charset="-120"/>
-              </a:rPr>
-              <a:t>2,19 €</a:t>
-            </a:r>
-            <a:endParaRPr lang="en-US" sz="1150" dirty="0"/>
-          </a:p>
-        </p:txBody>
-      </p:sp>
-      <p:sp>
-        <p:nvSpPr>
-          <p:cNvPr id="20" name="Text 18"/>
-          <p:cNvSpPr/>
-          <p:nvPr/>
-        </p:nvSpPr>
-        <p:spPr>
-          <a:xfrm>
-            <a:off x="4434840" y="3849624"/>
-            <a:ext cx="1737360" cy="292608"/>
-          </a:xfrm>
-          <a:prstGeom prst="rect">
-            <a:avLst/>
-          </a:prstGeom>
-          <a:noFill/>
-          <a:ln/>
-        </p:spPr>
-        <p:txBody>
-          <a:bodyPr wrap="square" lIns="0" tIns="0" rIns="0" bIns="0" rtlCol="0" anchor="ctr"/>
-          <a:lstStyle/>
-          <a:p>
-            <a:pPr indent="0" marL="0">
-              <a:buNone/>
-            </a:pPr>
-            <a:r>
-              <a:rPr lang="en-US" sz="1150" b="1" dirty="0">
-                <a:solidFill>
-                  <a:srgbClr val="12150F"/>
-                </a:solidFill>
-                <a:latin typeface="Arial" pitchFamily="34" charset="0"/>
-                <a:ea typeface="Arial" pitchFamily="34" charset="-122"/>
-                <a:cs typeface="Arial" pitchFamily="34" charset="-120"/>
-              </a:rPr>
-              <a:t>Gouda am Stück</a:t>
-            </a:r>
-            <a:endParaRPr lang="en-US" sz="1150" dirty="0"/>
-          </a:p>
-        </p:txBody>
-      </p:sp>
-      <p:sp>
-        <p:nvSpPr>
-          <p:cNvPr id="21" name="Text 19"/>
-          <p:cNvSpPr/>
-          <p:nvPr/>
-        </p:nvSpPr>
-        <p:spPr>
-          <a:xfrm>
-            <a:off x="6172200" y="3849624"/>
-            <a:ext cx="1508760" cy="292608"/>
-          </a:xfrm>
-          <a:prstGeom prst="rect">
-            <a:avLst/>
-          </a:prstGeom>
-          <a:noFill/>
-          <a:ln/>
-        </p:spPr>
-        <p:txBody>
-          <a:bodyPr wrap="square" lIns="0" tIns="0" rIns="0" bIns="0" rtlCol="0" anchor="ctr"/>
-          <a:lstStyle/>
-          <a:p>
-            <a:pPr indent="0" marL="0">
-              <a:buNone/>
-            </a:pPr>
-            <a:r>
-              <a:rPr lang="en-US" sz="1000" dirty="0">
-                <a:solidFill>
-                  <a:srgbClr val="77807A"/>
-                </a:solidFill>
-                <a:latin typeface="Arial" pitchFamily="34" charset="0"/>
-                <a:ea typeface="Arial" pitchFamily="34" charset="-122"/>
-                <a:cs typeface="Arial" pitchFamily="34" charset="-120"/>
-              </a:rPr>
-              <a:t>0,32 kg × 12,90 €/kg</a:t>
-            </a:r>
-            <a:endParaRPr lang="en-US" sz="1000" dirty="0"/>
-          </a:p>
-        </p:txBody>
-      </p:sp>
-      <p:sp>
-        <p:nvSpPr>
-          <p:cNvPr id="22" name="Text 20"/>
-          <p:cNvSpPr/>
-          <p:nvPr/>
-        </p:nvSpPr>
-        <p:spPr>
-          <a:xfrm>
-            <a:off x="7589520" y="3849624"/>
-            <a:ext cx="685800" cy="292608"/>
-          </a:xfrm>
-          <a:prstGeom prst="rect">
-            <a:avLst/>
-          </a:prstGeom>
-          <a:noFill/>
-          <a:ln/>
-        </p:spPr>
-        <p:txBody>
-          <a:bodyPr wrap="square" lIns="0" tIns="0" rIns="0" bIns="0" rtlCol="0" anchor="ctr"/>
-          <a:lstStyle/>
-          <a:p>
-            <a:pPr algn="r" indent="0" marL="0">
-              <a:buNone/>
-            </a:pPr>
-            <a:r>
-              <a:rPr lang="en-US" sz="1150" b="1" dirty="0">
-                <a:solidFill>
-                  <a:srgbClr val="12150F"/>
-                </a:solidFill>
-                <a:latin typeface="Arial" pitchFamily="34" charset="0"/>
-                <a:ea typeface="Arial" pitchFamily="34" charset="-122"/>
-                <a:cs typeface="Arial" pitchFamily="34" charset="-120"/>
-              </a:rPr>
-              <a:t>4,13 €</a:t>
-            </a:r>
-            <a:endParaRPr lang="en-US" sz="1150" dirty="0"/>
-          </a:p>
-        </p:txBody>
-      </p:sp>
-      <p:sp>
-        <p:nvSpPr>
-          <p:cNvPr id="23" name="Text 21"/>
-          <p:cNvSpPr/>
-          <p:nvPr/>
-        </p:nvSpPr>
-        <p:spPr>
-          <a:xfrm>
-            <a:off x="4434840" y="4197096"/>
-            <a:ext cx="3840480" cy="292608"/>
-          </a:xfrm>
-          <a:prstGeom prst="rect">
-            <a:avLst/>
-          </a:prstGeom>
-          <a:noFill/>
-          <a:ln/>
-        </p:spPr>
-        <p:txBody>
-          <a:bodyPr wrap="square" lIns="0" tIns="0" rIns="0" bIns="0" rtlCol="0" anchor="ctr"/>
-          <a:lstStyle/>
-          <a:p>
-            <a:pPr indent="0" marL="0">
-              <a:buNone/>
-            </a:pPr>
-            <a:r>
-              <a:rPr lang="en-US" sz="1050" dirty="0">
-                <a:solidFill>
-                  <a:srgbClr val="77807A"/>
-                </a:solidFill>
-                <a:latin typeface="Arial" pitchFamily="34" charset="0"/>
-                <a:ea typeface="Arial" pitchFamily="34" charset="-122"/>
-                <a:cs typeface="Arial" pitchFamily="34" charset="-120"/>
-              </a:rPr>
-              <a:t>… und fünf weitere Positionen dieses Bons</a:t>
-            </a:r>
-            <a:endParaRPr lang="en-US" sz="1050" dirty="0"/>
+              <a:t>Beispieldaten.</a:t>
+            </a:r>
+            <a:endParaRPr lang="en-US" sz="900" dirty="0"/>
           </a:p>
         </p:txBody>
       </p:sp>
@@ -3899,12 +3304,12 @@
         </p:nvSpPr>
         <p:spPr>
           <a:xfrm>
-            <a:off x="694944" y="409194"/>
-            <a:ext cx="1936547" cy="4434840"/>
+            <a:off x="6476560" y="409194"/>
+            <a:ext cx="2045648" cy="4434840"/>
           </a:xfrm>
           <a:prstGeom prst="roundRect">
             <a:avLst>
-              <a:gd name="adj" fmla="val 9444"/>
+              <a:gd name="adj" fmla="val 8940"/>
             </a:avLst>
           </a:prstGeom>
           <a:solidFill>
@@ -3927,7 +3332,7 @@
       </p:sp>
       <p:pic>
         <p:nvPicPr>
-          <p:cNvPr id="3" name="Image 0" descr="/var/tmp/deck/img/uebersicht.png">    </p:cNvPr>
+          <p:cNvPr id="3" name="Image 0" descr="/var/tmp/deck/img/bestpreise.png">    </p:cNvPr>
           <p:cNvPicPr>
             <a:picLocks noChangeAspect="1"/>
           </p:cNvPicPr>
@@ -3941,8 +3346,8 @@
         </p:blipFill>
         <p:spPr>
           <a:xfrm>
-            <a:off x="658368" y="354330"/>
-            <a:ext cx="1936547" cy="4434840"/>
+            <a:off x="6439984" y="354330"/>
+            <a:ext cx="2045648" cy="4434840"/>
           </a:xfrm>
           <a:prstGeom prst="rect">
             <a:avLst/>
@@ -3957,8 +3362,8 @@
         </p:nvSpPr>
         <p:spPr>
           <a:xfrm>
-            <a:off x="3280715" y="1417320"/>
-            <a:ext cx="5223205" cy="1005840"/>
+            <a:off x="594360" y="822960"/>
+            <a:ext cx="5159824" cy="1005840"/>
           </a:xfrm>
           <a:prstGeom prst="rect">
             <a:avLst/>
@@ -3985,10 +3390,30 @@
                 <a:ea typeface="Arial" pitchFamily="34" charset="-122"/>
                 <a:cs typeface="Arial" pitchFamily="34" charset="-120"/>
               </a:rPr>
-              <a:t>Der Monat auf einen Blick.</a:t>
+              <a:t>Dieselbe Butter,</a:t>
             </a:r>
             <a:endParaRPr lang="en-US" sz="3000" dirty="0"/>
           </a:p>
+          <a:p>
+            <a:pPr algn="l" indent="0" marL="0">
+              <a:lnSpc>
+                <a:spcPct val="105000"/>
+              </a:lnSpc>
+              <a:buNone/>
+            </a:pPr>
+            <a:r>
+              <a:rPr lang="en-US" sz="3000" b="1" dirty="0">
+                <a:solidFill>
+                  <a:srgbClr val="12150F"/>
+                </a:solidFill>
+                <a:latin typeface="Arial" pitchFamily="34" charset="0"/>
+                <a:ea typeface="Arial" pitchFamily="34" charset="-122"/>
+                <a:cs typeface="Arial" pitchFamily="34" charset="-120"/>
+              </a:rPr>
+              <a:t>drei Preise.</a:t>
+            </a:r>
+            <a:endParaRPr lang="en-US" sz="3000" dirty="0"/>
+          </a:p>
         </p:txBody>
       </p:sp>
       <p:sp>
@@ -3999,8 +3424,8 @@
         </p:nvSpPr>
         <p:spPr>
           <a:xfrm>
-            <a:off x="3280715" y="2377440"/>
-            <a:ext cx="5223205" cy="1463040"/>
+            <a:off x="594360" y="2148840"/>
+            <a:ext cx="5159824" cy="914400"/>
           </a:xfrm>
           <a:prstGeom prst="rect">
             <a:avLst/>
@@ -4027,7 +3452,7 @@
                 <a:ea typeface="Arial" pitchFamily="34" charset="-122"/>
                 <a:cs typeface="Arial" pitchFamily="34" charset="-120"/>
               </a:rPr>
-              <a:t>Was bisher zusammengekommen ist, wie viel vom Budget noch übrig ist – und wohin das Geld geflossen ist. Die Hochrechnung sagt, wo der Monat endet, wenn es so weitergeht wie bisher.</a:t>
+              <a:t>Die App merkt sich jeden Preis bei jedem Händler. Beim nächsten Einkauf weißt du, wo dasselbe Produkt zuletzt am günstigsten war.</a:t>
             </a:r>
             <a:endParaRPr lang="en-US" sz="1400" dirty="0"/>
           </a:p>
@@ -4041,8 +3466,8 @@
         </p:nvSpPr>
         <p:spPr>
           <a:xfrm>
-            <a:off x="3280715" y="4576572"/>
-            <a:ext cx="5223205" cy="274320"/>
+            <a:off x="594360" y="3154680"/>
+            <a:ext cx="1737360" cy="329184"/>
           </a:xfrm>
           <a:prstGeom prst="rect">
             <a:avLst/>
@@ -4055,6 +3480,240 @@
           <a:lstStyle/>
           <a:p>
             <a:pPr indent="0" marL="0">
+              <a:buNone/>
+            </a:pPr>
+            <a:r>
+              <a:rPr lang="en-US" sz="1300" b="1" dirty="0">
+                <a:solidFill>
+                  <a:srgbClr val="16915C"/>
+                </a:solidFill>
+                <a:latin typeface="Arial" pitchFamily="34" charset="0"/>
+                <a:ea typeface="Arial" pitchFamily="34" charset="-122"/>
+                <a:cs typeface="Arial" pitchFamily="34" charset="-120"/>
+              </a:rPr>
+              <a:t>ALDI SÜD</a:t>
+            </a:r>
+            <a:endParaRPr lang="en-US" sz="1300" dirty="0"/>
+          </a:p>
+        </p:txBody>
+      </p:sp>
+      <p:sp>
+        <p:nvSpPr>
+          <p:cNvPr id="7" name="Text 4"/>
+          <p:cNvSpPr/>
+          <p:nvPr/>
+        </p:nvSpPr>
+        <p:spPr>
+          <a:xfrm>
+            <a:off x="2331720" y="3154680"/>
+            <a:ext cx="914400" cy="329184"/>
+          </a:xfrm>
+          <a:prstGeom prst="rect">
+            <a:avLst/>
+          </a:prstGeom>
+          <a:noFill/>
+          <a:ln/>
+        </p:spPr>
+        <p:txBody>
+          <a:bodyPr wrap="square" lIns="0" tIns="0" rIns="0" bIns="0" rtlCol="0" anchor="ctr"/>
+          <a:lstStyle/>
+          <a:p>
+            <a:pPr algn="r" indent="0" marL="0">
+              <a:buNone/>
+            </a:pPr>
+            <a:r>
+              <a:rPr lang="en-US" sz="1300" b="1" dirty="0">
+                <a:solidFill>
+                  <a:srgbClr val="16915C"/>
+                </a:solidFill>
+                <a:latin typeface="Arial" pitchFamily="34" charset="0"/>
+                <a:ea typeface="Arial" pitchFamily="34" charset="-122"/>
+                <a:cs typeface="Arial" pitchFamily="34" charset="-120"/>
+              </a:rPr>
+              <a:t>2,19 €</a:t>
+            </a:r>
+            <a:endParaRPr lang="en-US" sz="1300" dirty="0"/>
+          </a:p>
+        </p:txBody>
+      </p:sp>
+      <p:sp>
+        <p:nvSpPr>
+          <p:cNvPr id="8" name="Text 5"/>
+          <p:cNvSpPr/>
+          <p:nvPr/>
+        </p:nvSpPr>
+        <p:spPr>
+          <a:xfrm>
+            <a:off x="594360" y="3538728"/>
+            <a:ext cx="1737360" cy="329184"/>
+          </a:xfrm>
+          <a:prstGeom prst="rect">
+            <a:avLst/>
+          </a:prstGeom>
+          <a:noFill/>
+          <a:ln/>
+        </p:spPr>
+        <p:txBody>
+          <a:bodyPr wrap="square" lIns="0" tIns="0" rIns="0" bIns="0" rtlCol="0" anchor="ctr"/>
+          <a:lstStyle/>
+          <a:p>
+            <a:pPr indent="0" marL="0">
+              <a:buNone/>
+            </a:pPr>
+            <a:r>
+              <a:rPr lang="en-US" sz="1300" dirty="0">
+                <a:solidFill>
+                  <a:srgbClr val="12150F"/>
+                </a:solidFill>
+                <a:latin typeface="Arial" pitchFamily="34" charset="0"/>
+                <a:ea typeface="Arial" pitchFamily="34" charset="-122"/>
+                <a:cs typeface="Arial" pitchFamily="34" charset="-120"/>
+              </a:rPr>
+              <a:t>REWE</a:t>
+            </a:r>
+            <a:endParaRPr lang="en-US" sz="1300" dirty="0"/>
+          </a:p>
+        </p:txBody>
+      </p:sp>
+      <p:sp>
+        <p:nvSpPr>
+          <p:cNvPr id="9" name="Text 6"/>
+          <p:cNvSpPr/>
+          <p:nvPr/>
+        </p:nvSpPr>
+        <p:spPr>
+          <a:xfrm>
+            <a:off x="2331720" y="3538728"/>
+            <a:ext cx="914400" cy="329184"/>
+          </a:xfrm>
+          <a:prstGeom prst="rect">
+            <a:avLst/>
+          </a:prstGeom>
+          <a:noFill/>
+          <a:ln/>
+        </p:spPr>
+        <p:txBody>
+          <a:bodyPr wrap="square" lIns="0" tIns="0" rIns="0" bIns="0" rtlCol="0" anchor="ctr"/>
+          <a:lstStyle/>
+          <a:p>
+            <a:pPr algn="r" indent="0" marL="0">
+              <a:buNone/>
+            </a:pPr>
+            <a:r>
+              <a:rPr lang="en-US" sz="1300" b="1" dirty="0">
+                <a:solidFill>
+                  <a:srgbClr val="12150F"/>
+                </a:solidFill>
+                <a:latin typeface="Arial" pitchFamily="34" charset="0"/>
+                <a:ea typeface="Arial" pitchFamily="34" charset="-122"/>
+                <a:cs typeface="Arial" pitchFamily="34" charset="-120"/>
+              </a:rPr>
+              <a:t>2,49 €</a:t>
+            </a:r>
+            <a:endParaRPr lang="en-US" sz="1300" dirty="0"/>
+          </a:p>
+        </p:txBody>
+      </p:sp>
+      <p:sp>
+        <p:nvSpPr>
+          <p:cNvPr id="10" name="Text 7"/>
+          <p:cNvSpPr/>
+          <p:nvPr/>
+        </p:nvSpPr>
+        <p:spPr>
+          <a:xfrm>
+            <a:off x="594360" y="3922776"/>
+            <a:ext cx="1737360" cy="329184"/>
+          </a:xfrm>
+          <a:prstGeom prst="rect">
+            <a:avLst/>
+          </a:prstGeom>
+          <a:noFill/>
+          <a:ln/>
+        </p:spPr>
+        <p:txBody>
+          <a:bodyPr wrap="square" lIns="0" tIns="0" rIns="0" bIns="0" rtlCol="0" anchor="ctr"/>
+          <a:lstStyle/>
+          <a:p>
+            <a:pPr indent="0" marL="0">
+              <a:buNone/>
+            </a:pPr>
+            <a:r>
+              <a:rPr lang="en-US" sz="1300" dirty="0">
+                <a:solidFill>
+                  <a:srgbClr val="12150F"/>
+                </a:solidFill>
+                <a:latin typeface="Arial" pitchFamily="34" charset="0"/>
+                <a:ea typeface="Arial" pitchFamily="34" charset="-122"/>
+                <a:cs typeface="Arial" pitchFamily="34" charset="-120"/>
+              </a:rPr>
+              <a:t>Edeka</a:t>
+            </a:r>
+            <a:endParaRPr lang="en-US" sz="1300" dirty="0"/>
+          </a:p>
+        </p:txBody>
+      </p:sp>
+      <p:sp>
+        <p:nvSpPr>
+          <p:cNvPr id="11" name="Text 8"/>
+          <p:cNvSpPr/>
+          <p:nvPr/>
+        </p:nvSpPr>
+        <p:spPr>
+          <a:xfrm>
+            <a:off x="2331720" y="3922776"/>
+            <a:ext cx="914400" cy="329184"/>
+          </a:xfrm>
+          <a:prstGeom prst="rect">
+            <a:avLst/>
+          </a:prstGeom>
+          <a:noFill/>
+          <a:ln/>
+        </p:spPr>
+        <p:txBody>
+          <a:bodyPr wrap="square" lIns="0" tIns="0" rIns="0" bIns="0" rtlCol="0" anchor="ctr"/>
+          <a:lstStyle/>
+          <a:p>
+            <a:pPr algn="r" indent="0" marL="0">
+              <a:buNone/>
+            </a:pPr>
+            <a:r>
+              <a:rPr lang="en-US" sz="1300" b="1" dirty="0">
+                <a:solidFill>
+                  <a:srgbClr val="12150F"/>
+                </a:solidFill>
+                <a:latin typeface="Arial" pitchFamily="34" charset="0"/>
+                <a:ea typeface="Arial" pitchFamily="34" charset="-122"/>
+                <a:cs typeface="Arial" pitchFamily="34" charset="-120"/>
+              </a:rPr>
+              <a:t>2,59 €</a:t>
+            </a:r>
+            <a:endParaRPr lang="en-US" sz="1300" dirty="0"/>
+          </a:p>
+        </p:txBody>
+      </p:sp>
+      <p:sp>
+        <p:nvSpPr>
+          <p:cNvPr id="12" name="Text 9"/>
+          <p:cNvSpPr/>
+          <p:nvPr/>
+        </p:nvSpPr>
+        <p:spPr>
+          <a:xfrm>
+            <a:off x="594360" y="4640580"/>
+            <a:ext cx="3657600" cy="274320"/>
+          </a:xfrm>
+          <a:prstGeom prst="rect">
+            <a:avLst/>
+          </a:prstGeom>
+          <a:noFill/>
+          <a:ln/>
+        </p:spPr>
+        <p:txBody>
+          <a:bodyPr wrap="square" lIns="0" tIns="0" rIns="0" bIns="0" rtlCol="0" anchor="ctr"/>
+          <a:lstStyle/>
+          <a:p>
+            <a:pPr algn="l" indent="0" marL="0">
               <a:buNone/>
             </a:pPr>
             <a:r>
@@ -4112,7 +3771,7 @@
         </p:nvSpPr>
         <p:spPr>
           <a:xfrm>
-            <a:off x="6476560" y="409194"/>
+            <a:off x="694944" y="409194"/>
             <a:ext cx="2045648" cy="4434840"/>
           </a:xfrm>
           <a:prstGeom prst="roundRect">
@@ -4140,7 +3799,7 @@
       </p:sp>
       <p:pic>
         <p:nvPicPr>
-          <p:cNvPr id="3" name="Image 0" descr="/var/tmp/deck/img/bestpreise.png">    </p:cNvPr>
+          <p:cNvPr id="3" name="Image 0" descr="/var/tmp/deck/img/gesundheit.png">    </p:cNvPr>
           <p:cNvPicPr>
             <a:picLocks noChangeAspect="1"/>
           </p:cNvPicPr>
@@ -4154,7 +3813,7 @@
         </p:blipFill>
         <p:spPr>
           <a:xfrm>
-            <a:off x="6439984" y="354330"/>
+            <a:off x="658368" y="354330"/>
             <a:ext cx="2045648" cy="4434840"/>
           </a:xfrm>
           <a:prstGeom prst="rect">
@@ -4170,8 +3829,8 @@
         </p:nvSpPr>
         <p:spPr>
           <a:xfrm>
-            <a:off x="594360" y="822960"/>
-            <a:ext cx="5159824" cy="1005840"/>
+            <a:off x="3389816" y="914400"/>
+            <a:ext cx="5114104" cy="1005840"/>
           </a:xfrm>
           <a:prstGeom prst="rect">
             <a:avLst/>
@@ -4198,7 +3857,7 @@
                 <a:ea typeface="Arial" pitchFamily="34" charset="-122"/>
                 <a:cs typeface="Arial" pitchFamily="34" charset="-120"/>
               </a:rPr>
-              <a:t>Dieselbe Butter,</a:t>
+              <a:t>Was gesund heißt,</a:t>
             </a:r>
             <a:endParaRPr lang="en-US" sz="3000" dirty="0"/>
           </a:p>
@@ -4218,7 +3877,7 @@
                 <a:ea typeface="Arial" pitchFamily="34" charset="-122"/>
                 <a:cs typeface="Arial" pitchFamily="34" charset="-120"/>
               </a:rPr>
-              <a:t>drei Preise.</a:t>
+              <a:t>legst du selbst fest.</a:t>
             </a:r>
             <a:endParaRPr lang="en-US" sz="3000" dirty="0"/>
           </a:p>
@@ -4232,8 +3891,8 @@
         </p:nvSpPr>
         <p:spPr>
           <a:xfrm>
-            <a:off x="594360" y="2148840"/>
-            <a:ext cx="5159824" cy="914400"/>
+            <a:off x="3389816" y="2240280"/>
+            <a:ext cx="5114104" cy="1737360"/>
           </a:xfrm>
           <a:prstGeom prst="rect">
             <a:avLst/>
@@ -4260,7 +3919,7 @@
                 <a:ea typeface="Arial" pitchFamily="34" charset="-122"/>
                 <a:cs typeface="Arial" pitchFamily="34" charset="-120"/>
               </a:rPr>
-              <a:t>Die App merkt sich jeden Preis bei jedem Händler. Beim nächsten Einkauf weißt du, wo dasselbe Produkt zuletzt am günstigsten war.</a:t>
+              <a:t>Jedes Produkt bekommt Merkmale – hochverarbeitet, Zucker, Weizen, Bio. Daraus entsteht ein Wert zwischen 0 und 100, und du siehst, wie viel Geld in welches Merkmal fließt. Wie schwer ein Merkmal wiegt, stellst du in den Einstellungen ein.</a:t>
             </a:r>
             <a:endParaRPr lang="en-US" sz="1400" dirty="0"/>
           </a:p>
@@ -4274,8 +3933,8 @@
         </p:nvSpPr>
         <p:spPr>
           <a:xfrm>
-            <a:off x="594360" y="3154680"/>
-            <a:ext cx="1737360" cy="329184"/>
+            <a:off x="3389816" y="4640580"/>
+            <a:ext cx="3657600" cy="274320"/>
           </a:xfrm>
           <a:prstGeom prst="rect">
             <a:avLst/>
@@ -4287,241 +3946,7 @@
           <a:bodyPr wrap="square" lIns="0" tIns="0" rIns="0" bIns="0" rtlCol="0" anchor="ctr"/>
           <a:lstStyle/>
           <a:p>
-            <a:pPr indent="0" marL="0">
-              <a:buNone/>
-            </a:pPr>
-            <a:r>
-              <a:rPr lang="en-US" sz="1300" b="1" dirty="0">
-                <a:solidFill>
-                  <a:srgbClr val="16915C"/>
-                </a:solidFill>
-                <a:latin typeface="Arial" pitchFamily="34" charset="0"/>
-                <a:ea typeface="Arial" pitchFamily="34" charset="-122"/>
-                <a:cs typeface="Arial" pitchFamily="34" charset="-120"/>
-              </a:rPr>
-              <a:t>ALDI SÜD</a:t>
-            </a:r>
-            <a:endParaRPr lang="en-US" sz="1300" dirty="0"/>
-          </a:p>
-        </p:txBody>
-      </p:sp>
-      <p:sp>
-        <p:nvSpPr>
-          <p:cNvPr id="7" name="Text 4"/>
-          <p:cNvSpPr/>
-          <p:nvPr/>
-        </p:nvSpPr>
-        <p:spPr>
-          <a:xfrm>
-            <a:off x="2331720" y="3154680"/>
-            <a:ext cx="914400" cy="329184"/>
-          </a:xfrm>
-          <a:prstGeom prst="rect">
-            <a:avLst/>
-          </a:prstGeom>
-          <a:noFill/>
-          <a:ln/>
-        </p:spPr>
-        <p:txBody>
-          <a:bodyPr wrap="square" lIns="0" tIns="0" rIns="0" bIns="0" rtlCol="0" anchor="ctr"/>
-          <a:lstStyle/>
-          <a:p>
-            <a:pPr algn="r" indent="0" marL="0">
-              <a:buNone/>
-            </a:pPr>
-            <a:r>
-              <a:rPr lang="en-US" sz="1300" b="1" dirty="0">
-                <a:solidFill>
-                  <a:srgbClr val="16915C"/>
-                </a:solidFill>
-                <a:latin typeface="Arial" pitchFamily="34" charset="0"/>
-                <a:ea typeface="Arial" pitchFamily="34" charset="-122"/>
-                <a:cs typeface="Arial" pitchFamily="34" charset="-120"/>
-              </a:rPr>
-              <a:t>2,19 €</a:t>
-            </a:r>
-            <a:endParaRPr lang="en-US" sz="1300" dirty="0"/>
-          </a:p>
-        </p:txBody>
-      </p:sp>
-      <p:sp>
-        <p:nvSpPr>
-          <p:cNvPr id="8" name="Text 5"/>
-          <p:cNvSpPr/>
-          <p:nvPr/>
-        </p:nvSpPr>
-        <p:spPr>
-          <a:xfrm>
-            <a:off x="594360" y="3538728"/>
-            <a:ext cx="1737360" cy="329184"/>
-          </a:xfrm>
-          <a:prstGeom prst="rect">
-            <a:avLst/>
-          </a:prstGeom>
-          <a:noFill/>
-          <a:ln/>
-        </p:spPr>
-        <p:txBody>
-          <a:bodyPr wrap="square" lIns="0" tIns="0" rIns="0" bIns="0" rtlCol="0" anchor="ctr"/>
-          <a:lstStyle/>
-          <a:p>
-            <a:pPr indent="0" marL="0">
-              <a:buNone/>
-            </a:pPr>
-            <a:r>
-              <a:rPr lang="en-US" sz="1300" dirty="0">
-                <a:solidFill>
-                  <a:srgbClr val="12150F"/>
-                </a:solidFill>
-                <a:latin typeface="Arial" pitchFamily="34" charset="0"/>
-                <a:ea typeface="Arial" pitchFamily="34" charset="-122"/>
-                <a:cs typeface="Arial" pitchFamily="34" charset="-120"/>
-              </a:rPr>
-              <a:t>REWE</a:t>
-            </a:r>
-            <a:endParaRPr lang="en-US" sz="1300" dirty="0"/>
-          </a:p>
-        </p:txBody>
-      </p:sp>
-      <p:sp>
-        <p:nvSpPr>
-          <p:cNvPr id="9" name="Text 6"/>
-          <p:cNvSpPr/>
-          <p:nvPr/>
-        </p:nvSpPr>
-        <p:spPr>
-          <a:xfrm>
-            <a:off x="2331720" y="3538728"/>
-            <a:ext cx="914400" cy="329184"/>
-          </a:xfrm>
-          <a:prstGeom prst="rect">
-            <a:avLst/>
-          </a:prstGeom>
-          <a:noFill/>
-          <a:ln/>
-        </p:spPr>
-        <p:txBody>
-          <a:bodyPr wrap="square" lIns="0" tIns="0" rIns="0" bIns="0" rtlCol="0" anchor="ctr"/>
-          <a:lstStyle/>
-          <a:p>
-            <a:pPr algn="r" indent="0" marL="0">
-              <a:buNone/>
-            </a:pPr>
-            <a:r>
-              <a:rPr lang="en-US" sz="1300" b="1" dirty="0">
-                <a:solidFill>
-                  <a:srgbClr val="12150F"/>
-                </a:solidFill>
-                <a:latin typeface="Arial" pitchFamily="34" charset="0"/>
-                <a:ea typeface="Arial" pitchFamily="34" charset="-122"/>
-                <a:cs typeface="Arial" pitchFamily="34" charset="-120"/>
-              </a:rPr>
-              <a:t>2,49 €</a:t>
-            </a:r>
-            <a:endParaRPr lang="en-US" sz="1300" dirty="0"/>
-          </a:p>
-        </p:txBody>
-      </p:sp>
-      <p:sp>
-        <p:nvSpPr>
-          <p:cNvPr id="10" name="Text 7"/>
-          <p:cNvSpPr/>
-          <p:nvPr/>
-        </p:nvSpPr>
-        <p:spPr>
-          <a:xfrm>
-            <a:off x="594360" y="3922776"/>
-            <a:ext cx="1737360" cy="329184"/>
-          </a:xfrm>
-          <a:prstGeom prst="rect">
-            <a:avLst/>
-          </a:prstGeom>
-          <a:noFill/>
-          <a:ln/>
-        </p:spPr>
-        <p:txBody>
-          <a:bodyPr wrap="square" lIns="0" tIns="0" rIns="0" bIns="0" rtlCol="0" anchor="ctr"/>
-          <a:lstStyle/>
-          <a:p>
-            <a:pPr indent="0" marL="0">
-              <a:buNone/>
-            </a:pPr>
-            <a:r>
-              <a:rPr lang="en-US" sz="1300" dirty="0">
-                <a:solidFill>
-                  <a:srgbClr val="12150F"/>
-                </a:solidFill>
-                <a:latin typeface="Arial" pitchFamily="34" charset="0"/>
-                <a:ea typeface="Arial" pitchFamily="34" charset="-122"/>
-                <a:cs typeface="Arial" pitchFamily="34" charset="-120"/>
-              </a:rPr>
-              <a:t>Edeka</a:t>
-            </a:r>
-            <a:endParaRPr lang="en-US" sz="1300" dirty="0"/>
-          </a:p>
-        </p:txBody>
-      </p:sp>
-      <p:sp>
-        <p:nvSpPr>
-          <p:cNvPr id="11" name="Text 8"/>
-          <p:cNvSpPr/>
-          <p:nvPr/>
-        </p:nvSpPr>
-        <p:spPr>
-          <a:xfrm>
-            <a:off x="2331720" y="3922776"/>
-            <a:ext cx="914400" cy="329184"/>
-          </a:xfrm>
-          <a:prstGeom prst="rect">
-            <a:avLst/>
-          </a:prstGeom>
-          <a:noFill/>
-          <a:ln/>
-        </p:spPr>
-        <p:txBody>
-          <a:bodyPr wrap="square" lIns="0" tIns="0" rIns="0" bIns="0" rtlCol="0" anchor="ctr"/>
-          <a:lstStyle/>
-          <a:p>
-            <a:pPr algn="r" indent="0" marL="0">
-              <a:buNone/>
-            </a:pPr>
-            <a:r>
-              <a:rPr lang="en-US" sz="1300" b="1" dirty="0">
-                <a:solidFill>
-                  <a:srgbClr val="12150F"/>
-                </a:solidFill>
-                <a:latin typeface="Arial" pitchFamily="34" charset="0"/>
-                <a:ea typeface="Arial" pitchFamily="34" charset="-122"/>
-                <a:cs typeface="Arial" pitchFamily="34" charset="-120"/>
-              </a:rPr>
-              <a:t>2,59 €</a:t>
-            </a:r>
-            <a:endParaRPr lang="en-US" sz="1300" dirty="0"/>
-          </a:p>
-        </p:txBody>
-      </p:sp>
-      <p:sp>
-        <p:nvSpPr>
-          <p:cNvPr id="12" name="Text 9"/>
-          <p:cNvSpPr/>
-          <p:nvPr/>
-        </p:nvSpPr>
-        <p:spPr>
-          <a:xfrm>
-            <a:off x="594360" y="4668012"/>
-            <a:ext cx="3200400" cy="274320"/>
-          </a:xfrm>
-          <a:prstGeom prst="rect">
-            <a:avLst/>
-          </a:prstGeom>
-          <a:noFill/>
-          <a:ln/>
-        </p:spPr>
-        <p:txBody>
-          <a:bodyPr wrap="square" lIns="0" tIns="0" rIns="0" bIns="0" rtlCol="0" anchor="ctr"/>
-          <a:lstStyle/>
-          <a:p>
-            <a:pPr indent="0" marL="0">
+            <a:pPr algn="l" indent="0" marL="0">
               <a:buNone/>
             </a:pPr>
             <a:r>
@@ -4579,7 +4004,7 @@
         </p:nvSpPr>
         <p:spPr>
           <a:xfrm>
-            <a:off x="694944" y="409194"/>
+            <a:off x="6476560" y="409194"/>
             <a:ext cx="2045648" cy="4434840"/>
           </a:xfrm>
           <a:prstGeom prst="roundRect">
@@ -4607,7 +4032,7 @@
       </p:sp>
       <p:pic>
         <p:nvPicPr>
-          <p:cNvPr id="3" name="Image 0" descr="/var/tmp/deck/img/gesundheit.png">    </p:cNvPr>
+          <p:cNvPr id="3" name="Image 0" descr="/var/tmp/deck/img/zettel.png">    </p:cNvPr>
           <p:cNvPicPr>
             <a:picLocks noChangeAspect="1"/>
           </p:cNvPicPr>
@@ -4621,7 +4046,7 @@
         </p:blipFill>
         <p:spPr>
           <a:xfrm>
-            <a:off x="658368" y="354330"/>
+            <a:off x="6439984" y="354330"/>
             <a:ext cx="2045648" cy="4434840"/>
           </a:xfrm>
           <a:prstGeom prst="rect">
@@ -4637,8 +4062,8 @@
         </p:nvSpPr>
         <p:spPr>
           <a:xfrm>
-            <a:off x="3389816" y="914400"/>
-            <a:ext cx="5114104" cy="1005840"/>
+            <a:off x="594360" y="1188720"/>
+            <a:ext cx="5159824" cy="1005840"/>
           </a:xfrm>
           <a:prstGeom prst="rect">
             <a:avLst/>
@@ -4665,7 +4090,7 @@
                 <a:ea typeface="Arial" pitchFamily="34" charset="-122"/>
                 <a:cs typeface="Arial" pitchFamily="34" charset="-120"/>
               </a:rPr>
-              <a:t>Was gesund heißt,</a:t>
+              <a:t>Der Einkaufszettel</a:t>
             </a:r>
             <a:endParaRPr lang="en-US" sz="3000" dirty="0"/>
           </a:p>
@@ -4685,7 +4110,7 @@
                 <a:ea typeface="Arial" pitchFamily="34" charset="-122"/>
                 <a:cs typeface="Arial" pitchFamily="34" charset="-120"/>
               </a:rPr>
-              <a:t>legst du selbst fest.</a:t>
+              <a:t>schreibt sich selbst.</a:t>
             </a:r>
             <a:endParaRPr lang="en-US" sz="3000" dirty="0"/>
           </a:p>
@@ -4699,8 +4124,8 @@
         </p:nvSpPr>
         <p:spPr>
           <a:xfrm>
-            <a:off x="3389816" y="2240280"/>
-            <a:ext cx="5114104" cy="1737360"/>
+            <a:off x="594360" y="2697480"/>
+            <a:ext cx="5159824" cy="1280160"/>
           </a:xfrm>
           <a:prstGeom prst="rect">
             <a:avLst/>
@@ -4727,7 +4152,7 @@
                 <a:ea typeface="Arial" pitchFamily="34" charset="-122"/>
                 <a:cs typeface="Arial" pitchFamily="34" charset="-120"/>
               </a:rPr>
-              <a:t>Jedes Produkt bekommt Merkmale – hochverarbeitet, Zucker, Weizen, Bio. Daraus entsteht ein Wert zwischen 0 und 100, und du siehst, wie viel Geld in welches Merkmal fließt. Wie schwer ein Merkmal wiegt, stellst du in den Einstellungen ein.</a:t>
+              <a:t>Aus den bisherigen Einkäufen entsteht der Wochenbedarf: was üblicherweise wieder dran ist, in welcher Menge – geschätzt mit deinen bisher günstigsten Preisen.</a:t>
             </a:r>
             <a:endParaRPr lang="en-US" sz="1400" dirty="0"/>
           </a:p>
@@ -4741,8 +4166,8 @@
         </p:nvSpPr>
         <p:spPr>
           <a:xfrm>
-            <a:off x="3389816" y="4576572"/>
-            <a:ext cx="5114104" cy="274320"/>
+            <a:off x="594360" y="4640580"/>
+            <a:ext cx="3657600" cy="274320"/>
           </a:xfrm>
           <a:prstGeom prst="rect">
             <a:avLst/>
@@ -4754,7 +4179,7 @@
           <a:bodyPr wrap="square" lIns="0" tIns="0" rIns="0" bIns="0" rtlCol="0" anchor="ctr"/>
           <a:lstStyle/>
           <a:p>
-            <a:pPr indent="0" marL="0">
+            <a:pPr algn="l" indent="0" marL="0">
               <a:buNone/>
             </a:pPr>
             <a:r>
@@ -4786,7 +4211,7 @@
     <p:bg>
       <p:bgPr>
         <a:solidFill>
-          <a:srgbClr val="F4F5F3"/>
+          <a:srgbClr val="12150F"/>
         </a:solidFill>
       </p:bgPr>
     </p:bg>
@@ -4806,202 +4231,525 @@
       </p:grpSpPr>
       <p:sp>
         <p:nvSpPr>
-          <p:cNvPr id="2" name="Shape 0"/>
-          <p:cNvSpPr/>
-          <p:nvPr/>
-        </p:nvSpPr>
-        <p:spPr>
-          <a:xfrm>
-            <a:off x="6476560" y="409194"/>
-            <a:ext cx="2045648" cy="4434840"/>
+          <p:cNvPr id="2" name="Text 0"/>
+          <p:cNvSpPr/>
+          <p:nvPr/>
+        </p:nvSpPr>
+        <p:spPr>
+          <a:xfrm>
+            <a:off x="594360" y="777240"/>
+            <a:ext cx="7955280" cy="1188720"/>
+          </a:xfrm>
+          <a:prstGeom prst="rect">
+            <a:avLst/>
+          </a:prstGeom>
+          <a:noFill/>
+          <a:ln/>
+        </p:spPr>
+        <p:txBody>
+          <a:bodyPr wrap="square" lIns="0" tIns="0" rIns="0" bIns="0" rtlCol="0" anchor="t"/>
+          <a:lstStyle/>
+          <a:p>
+            <a:pPr algn="l" indent="0" marL="0">
+              <a:lnSpc>
+                <a:spcPct val="105000"/>
+              </a:lnSpc>
+              <a:buNone/>
+            </a:pPr>
+            <a:r>
+              <a:rPr lang="en-US" sz="3000" b="1" dirty="0">
+                <a:solidFill>
+                  <a:srgbClr val="F4F5F3"/>
+                </a:solidFill>
+                <a:latin typeface="Arial" pitchFamily="34" charset="0"/>
+                <a:ea typeface="Arial" pitchFamily="34" charset="-122"/>
+                <a:cs typeface="Arial" pitchFamily="34" charset="-120"/>
+              </a:rPr>
+              <a:t>Kein Produkt.</a:t>
+            </a:r>
+            <a:endParaRPr lang="en-US" sz="3000" dirty="0"/>
+          </a:p>
+          <a:p>
+            <a:pPr algn="l" indent="0" marL="0">
+              <a:lnSpc>
+                <a:spcPct val="105000"/>
+              </a:lnSpc>
+              <a:buNone/>
+            </a:pPr>
+            <a:r>
+              <a:rPr lang="en-US" sz="3000" b="1" dirty="0">
+                <a:solidFill>
+                  <a:srgbClr val="F4F5F3"/>
+                </a:solidFill>
+                <a:latin typeface="Arial" pitchFamily="34" charset="0"/>
+                <a:ea typeface="Arial" pitchFamily="34" charset="-122"/>
+                <a:cs typeface="Arial" pitchFamily="34" charset="-120"/>
+              </a:rPr>
+              <a:t>Ein Werkzeug für den eigenen Haushalt.</a:t>
+            </a:r>
+            <a:endParaRPr lang="en-US" sz="3000" dirty="0"/>
+          </a:p>
+        </p:txBody>
+      </p:sp>
+      <p:sp>
+        <p:nvSpPr>
+          <p:cNvPr id="3" name="Text 1"/>
+          <p:cNvSpPr/>
+          <p:nvPr/>
+        </p:nvSpPr>
+        <p:spPr>
+          <a:xfrm>
+            <a:off x="594360" y="2057400"/>
+            <a:ext cx="7315200" cy="457200"/>
+          </a:xfrm>
+          <a:prstGeom prst="rect">
+            <a:avLst/>
+          </a:prstGeom>
+          <a:noFill/>
+          <a:ln/>
+        </p:spPr>
+        <p:txBody>
+          <a:bodyPr wrap="square" lIns="0" tIns="0" rIns="0" bIns="0" rtlCol="0" anchor="ctr"/>
+          <a:lstStyle/>
+          <a:p>
+            <a:pPr indent="0" marL="0">
+              <a:lnSpc>
+                <a:spcPct val="130000"/>
+              </a:lnSpc>
+              <a:buNone/>
+            </a:pPr>
+            <a:r>
+              <a:rPr lang="en-US" sz="1400" dirty="0">
+                <a:solidFill>
+                  <a:srgbClr val="9AA49D"/>
+                </a:solidFill>
+                <a:latin typeface="Arial" pitchFamily="34" charset="0"/>
+                <a:ea typeface="Arial" pitchFamily="34" charset="-122"/>
+                <a:cs typeface="Arial" pitchFamily="34" charset="-120"/>
+              </a:rPr>
+              <a:t>Alles, was du gesehen hast, läuft. Der einzige laufende Posten ist die KI-Erkennung, die pro Bon abgerechnet wird.</a:t>
+            </a:r>
+            <a:endParaRPr lang="en-US" sz="1400" dirty="0"/>
+          </a:p>
+        </p:txBody>
+      </p:sp>
+      <p:sp>
+        <p:nvSpPr>
+          <p:cNvPr id="4" name="Shape 2"/>
+          <p:cNvSpPr/>
+          <p:nvPr/>
+        </p:nvSpPr>
+        <p:spPr>
+          <a:xfrm>
+            <a:off x="594360" y="2788920"/>
+            <a:ext cx="2468880" cy="1737360"/>
           </a:xfrm>
           <a:prstGeom prst="roundRect">
             <a:avLst>
-              <a:gd name="adj" fmla="val 8940"/>
+              <a:gd name="adj" fmla="val 8421"/>
             </a:avLst>
           </a:prstGeom>
           <a:solidFill>
-            <a:srgbClr val="FFFFFF"/>
+            <a:srgbClr val="1C201A"/>
           </a:solidFill>
-          <a:ln w="3175">
+          <a:ln w="9525">
             <a:solidFill>
-              <a:srgbClr val="FFFFFF"/>
+              <a:srgbClr val="2C312A"/>
             </a:solidFill>
             <a:prstDash val="solid"/>
           </a:ln>
           <a:effectLst>
-            <a:outerShdw sx="100000" sy="100000" kx="0" ky="0" algn="bl" rotWithShape="0" blurRad="279400" dist="63500" dir="5400000">
+            <a:outerShdw sx="100000" sy="100000" kx="0" ky="0" algn="bl" rotWithShape="0" blurRad="177800" dist="38100" dir="5400000">
               <a:srgbClr val="000000">
-                <a:alpha val="16000"/>
+                <a:alpha val="10000"/>
               </a:srgbClr>
             </a:outerShdw>
           </a:effectLst>
         </p:spPr>
       </p:sp>
-      <p:pic>
-        <p:nvPicPr>
-          <p:cNvPr id="3" name="Image 0" descr="/var/tmp/deck/img/zettel.png">    </p:cNvPr>
-          <p:cNvPicPr>
-            <a:picLocks noChangeAspect="1"/>
-          </p:cNvPicPr>
-          <p:nvPr/>
-        </p:nvPicPr>
-        <p:blipFill>
-          <a:blip r:embed="rId1"/>
-          <a:stretch>
-            <a:fillRect/>
-          </a:stretch>
-        </p:blipFill>
-        <p:spPr>
-          <a:xfrm>
-            <a:off x="6439984" y="354330"/>
-            <a:ext cx="2045648" cy="4434840"/>
-          </a:xfrm>
-          <a:prstGeom prst="rect">
-            <a:avLst/>
-          </a:prstGeom>
-        </p:spPr>
-      </p:pic>
-      <p:sp>
-        <p:nvSpPr>
-          <p:cNvPr id="4" name="Text 1"/>
-          <p:cNvSpPr/>
-          <p:nvPr/>
-        </p:nvSpPr>
-        <p:spPr>
-          <a:xfrm>
-            <a:off x="594360" y="1188720"/>
-            <a:ext cx="5159824" cy="1005840"/>
-          </a:xfrm>
-          <a:prstGeom prst="rect">
-            <a:avLst/>
-          </a:prstGeom>
-          <a:noFill/>
-          <a:ln/>
-        </p:spPr>
-        <p:txBody>
-          <a:bodyPr wrap="square" lIns="0" tIns="0" rIns="0" bIns="0" rtlCol="0" anchor="t"/>
-          <a:lstStyle/>
-          <a:p>
-            <a:pPr algn="l" indent="0" marL="0">
+      <p:sp>
+        <p:nvSpPr>
+          <p:cNvPr id="5" name="Shape 3"/>
+          <p:cNvSpPr/>
+          <p:nvPr/>
+        </p:nvSpPr>
+        <p:spPr>
+          <a:xfrm>
+            <a:off x="850392" y="3017520"/>
+            <a:ext cx="173736" cy="173736"/>
+          </a:xfrm>
+          <a:prstGeom prst="ellipse">
+            <a:avLst/>
+          </a:prstGeom>
+          <a:solidFill>
+            <a:srgbClr val="16915C"/>
+          </a:solidFill>
+          <a:ln w="12700">
+            <a:solidFill>
+              <a:srgbClr val="16915C"/>
+            </a:solidFill>
+            <a:prstDash val="solid"/>
+          </a:ln>
+        </p:spPr>
+      </p:sp>
+      <p:sp>
+        <p:nvSpPr>
+          <p:cNvPr id="6" name="Text 4"/>
+          <p:cNvSpPr/>
+          <p:nvPr/>
+        </p:nvSpPr>
+        <p:spPr>
+          <a:xfrm>
+            <a:off x="850392" y="3291840"/>
+            <a:ext cx="1965960" cy="256032"/>
+          </a:xfrm>
+          <a:prstGeom prst="rect">
+            <a:avLst/>
+          </a:prstGeom>
+          <a:noFill/>
+          <a:ln/>
+        </p:spPr>
+        <p:txBody>
+          <a:bodyPr wrap="square" lIns="0" tIns="0" rIns="0" bIns="0" rtlCol="0" anchor="ctr"/>
+          <a:lstStyle/>
+          <a:p>
+            <a:pPr indent="0" marL="0">
+              <a:buNone/>
+            </a:pPr>
+            <a:r>
+              <a:rPr lang="en-US" sz="1300" b="1" dirty="0">
+                <a:solidFill>
+                  <a:srgbClr val="F4F5F3"/>
+                </a:solidFill>
+                <a:latin typeface="Arial" pitchFamily="34" charset="0"/>
+                <a:ea typeface="Arial" pitchFamily="34" charset="-122"/>
+                <a:cs typeface="Arial" pitchFamily="34" charset="-120"/>
+              </a:rPr>
+              <a:t>Auf dem Telefon</a:t>
+            </a:r>
+            <a:endParaRPr lang="en-US" sz="1300" dirty="0"/>
+          </a:p>
+        </p:txBody>
+      </p:sp>
+      <p:sp>
+        <p:nvSpPr>
+          <p:cNvPr id="7" name="Text 5"/>
+          <p:cNvSpPr/>
+          <p:nvPr/>
+        </p:nvSpPr>
+        <p:spPr>
+          <a:xfrm>
+            <a:off x="850392" y="3602736"/>
+            <a:ext cx="1965960" cy="822960"/>
+          </a:xfrm>
+          <a:prstGeom prst="rect">
+            <a:avLst/>
+          </a:prstGeom>
+          <a:noFill/>
+          <a:ln/>
+        </p:spPr>
+        <p:txBody>
+          <a:bodyPr wrap="square" lIns="0" tIns="0" rIns="0" bIns="0" rtlCol="0" anchor="ctr"/>
+          <a:lstStyle/>
+          <a:p>
+            <a:pPr indent="0" marL="0">
               <a:lnSpc>
-                <a:spcPct val="105000"/>
+                <a:spcPct val="125000"/>
               </a:lnSpc>
               <a:buNone/>
             </a:pPr>
             <a:r>
-              <a:rPr lang="en-US" sz="3000" b="1" dirty="0">
-                <a:solidFill>
-                  <a:srgbClr val="12150F"/>
-                </a:solidFill>
-                <a:latin typeface="Arial" pitchFamily="34" charset="0"/>
-                <a:ea typeface="Arial" pitchFamily="34" charset="-122"/>
-                <a:cs typeface="Arial" pitchFamily="34" charset="-120"/>
-              </a:rPr>
-              <a:t>Der Einkaufszettel</a:t>
-            </a:r>
-            <a:endParaRPr lang="en-US" sz="3000" dirty="0"/>
-          </a:p>
-          <a:p>
-            <a:pPr algn="l" indent="0" marL="0">
+              <a:rPr lang="en-US" sz="1050" dirty="0">
+                <a:solidFill>
+                  <a:srgbClr val="9AA49D"/>
+                </a:solidFill>
+                <a:latin typeface="Arial" pitchFamily="34" charset="0"/>
+                <a:ea typeface="Arial" pitchFamily="34" charset="-122"/>
+                <a:cs typeface="Arial" pitchFamily="34" charset="-120"/>
+              </a:rPr>
+              <a:t>Läuft im Browser des iPhones, ohne App Store. Angemeldet wird sich mit dem Google-Konto.</a:t>
+            </a:r>
+            <a:endParaRPr lang="en-US" sz="1050" dirty="0"/>
+          </a:p>
+        </p:txBody>
+      </p:sp>
+      <p:sp>
+        <p:nvSpPr>
+          <p:cNvPr id="8" name="Shape 6"/>
+          <p:cNvSpPr/>
+          <p:nvPr/>
+        </p:nvSpPr>
+        <p:spPr>
+          <a:xfrm>
+            <a:off x="3383280" y="2788920"/>
+            <a:ext cx="2468880" cy="1737360"/>
+          </a:xfrm>
+          <a:prstGeom prst="roundRect">
+            <a:avLst>
+              <a:gd name="adj" fmla="val 8421"/>
+            </a:avLst>
+          </a:prstGeom>
+          <a:solidFill>
+            <a:srgbClr val="1C201A"/>
+          </a:solidFill>
+          <a:ln w="9525">
+            <a:solidFill>
+              <a:srgbClr val="2C312A"/>
+            </a:solidFill>
+            <a:prstDash val="solid"/>
+          </a:ln>
+          <a:effectLst>
+            <a:outerShdw sx="100000" sy="100000" kx="0" ky="0" algn="bl" rotWithShape="0" blurRad="177800" dist="38100" dir="5400000">
+              <a:srgbClr val="000000">
+                <a:alpha val="10000"/>
+              </a:srgbClr>
+            </a:outerShdw>
+          </a:effectLst>
+        </p:spPr>
+      </p:sp>
+      <p:sp>
+        <p:nvSpPr>
+          <p:cNvPr id="9" name="Shape 7"/>
+          <p:cNvSpPr/>
+          <p:nvPr/>
+        </p:nvSpPr>
+        <p:spPr>
+          <a:xfrm>
+            <a:off x="3639312" y="3017520"/>
+            <a:ext cx="173736" cy="173736"/>
+          </a:xfrm>
+          <a:prstGeom prst="ellipse">
+            <a:avLst/>
+          </a:prstGeom>
+          <a:solidFill>
+            <a:srgbClr val="16915C"/>
+          </a:solidFill>
+          <a:ln w="12700">
+            <a:solidFill>
+              <a:srgbClr val="16915C"/>
+            </a:solidFill>
+            <a:prstDash val="solid"/>
+          </a:ln>
+        </p:spPr>
+      </p:sp>
+      <p:sp>
+        <p:nvSpPr>
+          <p:cNvPr id="10" name="Text 8"/>
+          <p:cNvSpPr/>
+          <p:nvPr/>
+        </p:nvSpPr>
+        <p:spPr>
+          <a:xfrm>
+            <a:off x="3639312" y="3291840"/>
+            <a:ext cx="1965960" cy="256032"/>
+          </a:xfrm>
+          <a:prstGeom prst="rect">
+            <a:avLst/>
+          </a:prstGeom>
+          <a:noFill/>
+          <a:ln/>
+        </p:spPr>
+        <p:txBody>
+          <a:bodyPr wrap="square" lIns="0" tIns="0" rIns="0" bIns="0" rtlCol="0" anchor="ctr"/>
+          <a:lstStyle/>
+          <a:p>
+            <a:pPr indent="0" marL="0">
+              <a:buNone/>
+            </a:pPr>
+            <a:r>
+              <a:rPr lang="en-US" sz="1300" b="1" dirty="0">
+                <a:solidFill>
+                  <a:srgbClr val="F4F5F3"/>
+                </a:solidFill>
+                <a:latin typeface="Arial" pitchFamily="34" charset="0"/>
+                <a:ea typeface="Arial" pitchFamily="34" charset="-122"/>
+                <a:cs typeface="Arial" pitchFamily="34" charset="-120"/>
+              </a:rPr>
+              <a:t>Ohne Bonfoto</a:t>
+            </a:r>
+            <a:endParaRPr lang="en-US" sz="1300" dirty="0"/>
+          </a:p>
+        </p:txBody>
+      </p:sp>
+      <p:sp>
+        <p:nvSpPr>
+          <p:cNvPr id="11" name="Text 9"/>
+          <p:cNvSpPr/>
+          <p:nvPr/>
+        </p:nvSpPr>
+        <p:spPr>
+          <a:xfrm>
+            <a:off x="3639312" y="3602736"/>
+            <a:ext cx="1965960" cy="822960"/>
+          </a:xfrm>
+          <a:prstGeom prst="rect">
+            <a:avLst/>
+          </a:prstGeom>
+          <a:noFill/>
+          <a:ln/>
+        </p:spPr>
+        <p:txBody>
+          <a:bodyPr wrap="square" lIns="0" tIns="0" rIns="0" bIns="0" rtlCol="0" anchor="ctr"/>
+          <a:lstStyle/>
+          <a:p>
+            <a:pPr indent="0" marL="0">
               <a:lnSpc>
-                <a:spcPct val="105000"/>
+                <a:spcPct val="125000"/>
               </a:lnSpc>
               <a:buNone/>
             </a:pPr>
             <a:r>
-              <a:rPr lang="en-US" sz="3000" b="1" dirty="0">
-                <a:solidFill>
-                  <a:srgbClr val="12150F"/>
-                </a:solidFill>
-                <a:latin typeface="Arial" pitchFamily="34" charset="0"/>
-                <a:ea typeface="Arial" pitchFamily="34" charset="-122"/>
-                <a:cs typeface="Arial" pitchFamily="34" charset="-120"/>
-              </a:rPr>
-              <a:t>schreibt sich selbst.</a:t>
-            </a:r>
-            <a:endParaRPr lang="en-US" sz="3000" dirty="0"/>
-          </a:p>
-        </p:txBody>
-      </p:sp>
-      <p:sp>
-        <p:nvSpPr>
-          <p:cNvPr id="5" name="Text 2"/>
-          <p:cNvSpPr/>
-          <p:nvPr/>
-        </p:nvSpPr>
-        <p:spPr>
-          <a:xfrm>
-            <a:off x="594360" y="2697480"/>
-            <a:ext cx="5159824" cy="1280160"/>
-          </a:xfrm>
-          <a:prstGeom prst="rect">
-            <a:avLst/>
-          </a:prstGeom>
-          <a:noFill/>
-          <a:ln/>
-        </p:spPr>
-        <p:txBody>
-          <a:bodyPr wrap="square" lIns="0" tIns="0" rIns="0" bIns="0" rtlCol="0" anchor="t"/>
-          <a:lstStyle/>
-          <a:p>
-            <a:pPr algn="l" indent="0" marL="0">
+              <a:rPr lang="en-US" sz="1050" dirty="0">
+                <a:solidFill>
+                  <a:srgbClr val="9AA49D"/>
+                </a:solidFill>
+                <a:latin typeface="Arial" pitchFamily="34" charset="0"/>
+                <a:ea typeface="Arial" pitchFamily="34" charset="-122"/>
+                <a:cs typeface="Arial" pitchFamily="34" charset="-120"/>
+              </a:rPr>
+              <a:t>Gespeichert wird nur, was die KI aus dem Bon gelesen hat. Das Bild selbst wird nie abgelegt.</a:t>
+            </a:r>
+            <a:endParaRPr lang="en-US" sz="1050" dirty="0"/>
+          </a:p>
+        </p:txBody>
+      </p:sp>
+      <p:sp>
+        <p:nvSpPr>
+          <p:cNvPr id="12" name="Shape 10"/>
+          <p:cNvSpPr/>
+          <p:nvPr/>
+        </p:nvSpPr>
+        <p:spPr>
+          <a:xfrm>
+            <a:off x="6172200" y="2788920"/>
+            <a:ext cx="2468880" cy="1737360"/>
+          </a:xfrm>
+          <a:prstGeom prst="roundRect">
+            <a:avLst>
+              <a:gd name="adj" fmla="val 8421"/>
+            </a:avLst>
+          </a:prstGeom>
+          <a:solidFill>
+            <a:srgbClr val="1C201A"/>
+          </a:solidFill>
+          <a:ln w="9525">
+            <a:solidFill>
+              <a:srgbClr val="2C312A"/>
+            </a:solidFill>
+            <a:prstDash val="solid"/>
+          </a:ln>
+          <a:effectLst>
+            <a:outerShdw sx="100000" sy="100000" kx="0" ky="0" algn="bl" rotWithShape="0" blurRad="177800" dist="38100" dir="5400000">
+              <a:srgbClr val="000000">
+                <a:alpha val="10000"/>
+              </a:srgbClr>
+            </a:outerShdw>
+          </a:effectLst>
+        </p:spPr>
+      </p:sp>
+      <p:sp>
+        <p:nvSpPr>
+          <p:cNvPr id="13" name="Shape 11"/>
+          <p:cNvSpPr/>
+          <p:nvPr/>
+        </p:nvSpPr>
+        <p:spPr>
+          <a:xfrm>
+            <a:off x="6428232" y="3017520"/>
+            <a:ext cx="173736" cy="173736"/>
+          </a:xfrm>
+          <a:prstGeom prst="ellipse">
+            <a:avLst/>
+          </a:prstGeom>
+          <a:solidFill>
+            <a:srgbClr val="16915C"/>
+          </a:solidFill>
+          <a:ln w="12700">
+            <a:solidFill>
+              <a:srgbClr val="16915C"/>
+            </a:solidFill>
+            <a:prstDash val="solid"/>
+          </a:ln>
+        </p:spPr>
+      </p:sp>
+      <p:sp>
+        <p:nvSpPr>
+          <p:cNvPr id="14" name="Text 12"/>
+          <p:cNvSpPr/>
+          <p:nvPr/>
+        </p:nvSpPr>
+        <p:spPr>
+          <a:xfrm>
+            <a:off x="6428232" y="3291840"/>
+            <a:ext cx="1965960" cy="256032"/>
+          </a:xfrm>
+          <a:prstGeom prst="rect">
+            <a:avLst/>
+          </a:prstGeom>
+          <a:noFill/>
+          <a:ln/>
+        </p:spPr>
+        <p:txBody>
+          <a:bodyPr wrap="square" lIns="0" tIns="0" rIns="0" bIns="0" rtlCol="0" anchor="ctr"/>
+          <a:lstStyle/>
+          <a:p>
+            <a:pPr indent="0" marL="0">
+              <a:buNone/>
+            </a:pPr>
+            <a:r>
+              <a:rPr lang="en-US" sz="1300" b="1" dirty="0">
+                <a:solidFill>
+                  <a:srgbClr val="F4F5F3"/>
+                </a:solidFill>
+                <a:latin typeface="Arial" pitchFamily="34" charset="0"/>
+                <a:ea typeface="Arial" pitchFamily="34" charset="-122"/>
+                <a:cs typeface="Arial" pitchFamily="34" charset="-120"/>
+              </a:rPr>
+              <a:t>Für einen Haushalt</a:t>
+            </a:r>
+            <a:endParaRPr lang="en-US" sz="1300" dirty="0"/>
+          </a:p>
+        </p:txBody>
+      </p:sp>
+      <p:sp>
+        <p:nvSpPr>
+          <p:cNvPr id="15" name="Text 13"/>
+          <p:cNvSpPr/>
+          <p:nvPr/>
+        </p:nvSpPr>
+        <p:spPr>
+          <a:xfrm>
+            <a:off x="6428232" y="3602736"/>
+            <a:ext cx="1965960" cy="822960"/>
+          </a:xfrm>
+          <a:prstGeom prst="rect">
+            <a:avLst/>
+          </a:prstGeom>
+          <a:noFill/>
+          <a:ln/>
+        </p:spPr>
+        <p:txBody>
+          <a:bodyPr wrap="square" lIns="0" tIns="0" rIns="0" bIns="0" rtlCol="0" anchor="ctr"/>
+          <a:lstStyle/>
+          <a:p>
+            <a:pPr indent="0" marL="0">
               <a:lnSpc>
-                <a:spcPct val="130000"/>
+                <a:spcPct val="125000"/>
               </a:lnSpc>
               <a:buNone/>
             </a:pPr>
             <a:r>
-              <a:rPr lang="en-US" sz="1400" dirty="0">
-                <a:solidFill>
-                  <a:srgbClr val="77807A"/>
-                </a:solidFill>
-                <a:latin typeface="Arial" pitchFamily="34" charset="0"/>
-                <a:ea typeface="Arial" pitchFamily="34" charset="-122"/>
-                <a:cs typeface="Arial" pitchFamily="34" charset="-120"/>
-              </a:rPr>
-              <a:t>Aus den bisherigen Einkäufen entsteht der Wochenbedarf: was üblicherweise wieder dran ist, in welcher Menge – geschätzt mit deinen bisher günstigsten Preisen.</a:t>
-            </a:r>
-            <a:endParaRPr lang="en-US" sz="1400" dirty="0"/>
-          </a:p>
-        </p:txBody>
-      </p:sp>
-      <p:sp>
-        <p:nvSpPr>
-          <p:cNvPr id="6" name="Text 3"/>
-          <p:cNvSpPr/>
-          <p:nvPr/>
-        </p:nvSpPr>
-        <p:spPr>
-          <a:xfrm>
-            <a:off x="594360" y="4668012"/>
-            <a:ext cx="3200400" cy="274320"/>
-          </a:xfrm>
-          <a:prstGeom prst="rect">
-            <a:avLst/>
-          </a:prstGeom>
-          <a:noFill/>
-          <a:ln/>
-        </p:spPr>
-        <p:txBody>
-          <a:bodyPr wrap="square" lIns="0" tIns="0" rIns="0" bIns="0" rtlCol="0" anchor="ctr"/>
-          <a:lstStyle/>
-          <a:p>
-            <a:pPr indent="0" marL="0">
-              <a:buNone/>
-            </a:pPr>
-            <a:r>
-              <a:rPr lang="en-US" sz="900" dirty="0">
-                <a:solidFill>
-                  <a:srgbClr val="77807A"/>
-                </a:solidFill>
-                <a:latin typeface="Arial" pitchFamily="34" charset="0"/>
-                <a:ea typeface="Arial" pitchFamily="34" charset="-122"/>
-                <a:cs typeface="Arial" pitchFamily="34" charset="-120"/>
-              </a:rPr>
-              <a:t>Beispieldaten.</a:t>
-            </a:r>
-            <a:endParaRPr lang="en-US" sz="900" dirty="0"/>
+              <a:rPr lang="en-US" sz="1050" dirty="0">
+                <a:solidFill>
+                  <a:srgbClr val="9AA49D"/>
+                </a:solidFill>
+                <a:latin typeface="Arial" pitchFamily="34" charset="0"/>
+                <a:ea typeface="Arial" pitchFamily="34" charset="-122"/>
+                <a:cs typeface="Arial" pitchFamily="34" charset="-120"/>
+              </a:rPr>
+              <a:t>Mehrere Personen teilen sich Einkäufe, Budget und Zettel – und sehen nur die eigenen.</a:t>
+            </a:r>
+            <a:endParaRPr lang="en-US" sz="1050" dirty="0"/>
           </a:p>
         </p:txBody>
       </p:sp>

</xml_diff>